<commit_message>
Round-2 eval verdict, demo frontend, v2 GGUF ships in container
v2 (accuracy-weighted pairs + real SFT warm start): formal +0.50, beats v1
52W-40L. Kimi-BoN keeps leaderboard default. Node/Express demo page with
real harness outputs. Harness contract test: 3 clips, 33s, exit 0.

Co-Authored-By: Claude Fable 5 <noreply@anthropic.com>
</commit_message>
<xml_diff>
--- a/presentation/StyleForge.pptx
+++ b/presentation/StyleForge.pptx
@@ -3784,7 +3784,7 @@
                 <a:ea typeface="Arial" pitchFamily="34" charset="-122"/>
                 <a:cs typeface="Arial" pitchFamily="34" charset="-120"/>
               </a:rPr>
-              <a:t>Precedent: ACT I grand prize went to an RL project</a:t>
+              <a:t>Chosen by studying ACT I's winners: the grand prize went to an RL project; fine-tuning winners paired technique with a story</a:t>
             </a:r>
             <a:endParaRPr lang="en-US" sz="1350" dirty="0"/>
           </a:p>
@@ -3798,8 +3798,8 @@
         </p:nvSpPr>
         <p:spPr>
           <a:xfrm>
-            <a:off x="457200" y="4023360"/>
-            <a:ext cx="8229600" cy="685800"/>
+            <a:off x="457200" y="3977640"/>
+            <a:ext cx="8229600" cy="777240"/>
           </a:xfrm>
           <a:prstGeom prst="rect">
             <a:avLst/>
@@ -3815,7 +3815,7 @@
               <a:buNone/>
             </a:pPr>
             <a:r>
-              <a:rPr lang="en-US" sz="4000" b="1" dirty="0">
+              <a:rPr lang="en-US" sz="2200" b="1" dirty="0">
                 <a:solidFill>
                   <a:srgbClr val="ED1C24"/>
                 </a:solidFill>
@@ -3823,13 +3823,16 @@
                 <a:ea typeface="Arial Black" pitchFamily="34" charset="-122"/>
                 <a:cs typeface="Arial Black" pitchFamily="34" charset="-120"/>
               </a:rPr>
-              <a:t>0</a:t>
-            </a:r>
+              <a:t>Tone is trained, not prompted</a:t>
+            </a:r>
+            <a:endParaRPr lang="en-US" sz="2200" dirty="0"/>
+          </a:p>
+          <a:p>
             <a:pPr indent="0" marL="0">
               <a:buNone/>
             </a:pPr>
             <a:r>
-              <a:rPr lang="en-US" sz="1500" dirty="0">
+              <a:rPr lang="en-US" sz="1400" dirty="0">
                 <a:solidFill>
                   <a:srgbClr val="FFFFFF"/>
                 </a:solidFill>
@@ -3837,9 +3840,9 @@
                 <a:ea typeface="Arial" pitchFamily="34" charset="-122"/>
                 <a:cs typeface="Arial" pitchFamily="34" charset="-120"/>
               </a:rPr>
-              <a:t>   other teams are fine-tuning — tone is our trained edge, not our prompt's luck</a:t>
-            </a:r>
-            <a:endParaRPr lang="en-US" sz="4000" dirty="0"/>
+              <a:t>DPO on judge-ranked caption pairs — optimized against the exact signal the leaderboard scores.</a:t>
+            </a:r>
+            <a:endParaRPr lang="en-US" sz="2200" dirty="0"/>
           </a:p>
         </p:txBody>
       </p:sp>
@@ -6759,7 +6762,7 @@
                 <a:ea typeface="Arial Black" pitchFamily="34" charset="-122"/>
                 <a:cs typeface="Arial Black" pitchFamily="34" charset="-120"/>
               </a:rPr>
-              <a:t>Early Results — Real Clip, Real Judge Scores</a:t>
+              <a:t>The Eval: Measured Honestly</a:t>
             </a:r>
             <a:endParaRPr lang="en-US" sz="2800" dirty="0"/>
           </a:p>
@@ -6767,14 +6770,2137 @@
       </p:sp>
       <p:sp>
         <p:nvSpPr>
-          <p:cNvPr id="4" name="Shape 2"/>
-          <p:cNvSpPr/>
-          <p:nvPr/>
-        </p:nvSpPr>
-        <p:spPr>
-          <a:xfrm>
-            <a:off x="457200" y="1097280"/>
-            <a:ext cx="8229600" cy="658368"/>
+          <p:cNvPr id="4" name="Text 2"/>
+          <p:cNvSpPr/>
+          <p:nvPr/>
+        </p:nvSpPr>
+        <p:spPr>
+          <a:xfrm>
+            <a:off x="457200" y="868680"/>
+            <a:ext cx="8229600" cy="274320"/>
+          </a:xfrm>
+          <a:prstGeom prst="rect">
+            <a:avLst/>
+          </a:prstGeom>
+          <a:noFill/>
+          <a:ln/>
+        </p:spPr>
+        <p:txBody>
+          <a:bodyPr wrap="square" lIns="0" tIns="0" rIns="0" bIns="0" rtlCol="0" anchor="ctr"/>
+          <a:lstStyle/>
+          <a:p>
+            <a:pPr indent="0" marL="0">
+              <a:buNone/>
+            </a:pPr>
+            <a:r>
+              <a:rPr lang="en-US" sz="1200" dirty="0">
+                <a:solidFill>
+                  <a:srgbClr val="A8ADB8"/>
+                </a:solidFill>
+                <a:latin typeface="Arial" pitchFamily="34" charset="0"/>
+                <a:ea typeface="Arial" pitchFamily="34" charset="-122"/>
+                <a:cs typeface="Arial" pitchFamily="34" charset="-120"/>
+              </a:rPr>
+              <a:t>30 unseen scenes x 4 styles x 4 arms, scored by gpt-oss-120b (no model grades its own family)</a:t>
+            </a:r>
+            <a:endParaRPr lang="en-US" sz="1200" dirty="0"/>
+          </a:p>
+        </p:txBody>
+      </p:sp>
+      <p:graphicFrame>
+        <p:nvGraphicFramePr>
+          <p:cNvPr id="9" name="Table 0"/>
+          <p:cNvGraphicFramePr>
+            <a:graphicFrameLocks noGrp="1"/>
+          </p:cNvGraphicFramePr>
+          <p:nvPr>
+            <p:extLst>
+              <p:ext uri="{D42A27DB-BD31-4B8C-83A1-F6EECF244321}">
+                <p14:modId xmlns:p14="http://schemas.microsoft.com/office/powerpoint/2010/main" val="1579011935"/>
+              </p:ext>
+            </p:extLst>
+          </p:nvPr>
+        </p:nvGraphicFramePr>
+        <p:xfrm>
+          <a:off x="457200" y="1234440"/>
+          <a:ext cx="8229600" cy="914400"/>
+        </p:xfrm>
+        <a:graphic>
+          <a:graphicData uri="http://schemas.openxmlformats.org/drawingml/2006/table">
+            <a:tbl>
+              <a:tblPr/>
+              <a:tblGrid>
+                <a:gridCol w="2194560"/>
+                <a:gridCol w="1207008"/>
+                <a:gridCol w="1207008"/>
+                <a:gridCol w="1207008"/>
+                <a:gridCol w="1207008"/>
+                <a:gridCol w="1207008"/>
+              </a:tblGrid>
+              <a:tr h="310896">
+                <a:tc>
+                  <a:txBody>
+                    <a:bodyPr/>
+                    <a:lstStyle/>
+                    <a:p>
+                      <a:pPr algn="ctr" indent="0" marL="0">
+                        <a:buNone/>
+                      </a:pPr>
+                      <a:r>
+                        <a:rPr lang="en-US" sz="1100" b="1" dirty="0">
+                          <a:solidFill>
+                            <a:srgbClr val="A8ADB8"/>
+                          </a:solidFill>
+                          <a:latin typeface="Consolas" pitchFamily="34" charset="0"/>
+                          <a:ea typeface="Consolas" pitchFamily="34" charset="-122"/>
+                          <a:cs typeface="Consolas" pitchFamily="34" charset="-120"/>
+                        </a:rPr>
+                        <a:t>arm</a:t>
+                      </a:r>
+                      <a:endParaRPr lang="en-US" sz="1100" dirty="0">
+                        <a:latin typeface="Consolas" charset="0"/>
+                        <a:ea typeface="Consolas" charset="0"/>
+                        <a:cs typeface="Consolas" charset="0"/>
+                      </a:endParaRPr>
+                    </a:p>
+                  </a:txBody>
+                  <a:tcPr marL="91440" marR="91440" marT="45720" marB="45720" anchor="ctr">
+                    <a:lnL w="9525" cap="flat" cmpd="sng" algn="ctr">
+                      <a:solidFill>
+                        <a:srgbClr val="38383E"/>
+                      </a:solidFill>
+                      <a:prstDash val="solid"/>
+                      <a:round/>
+                      <a:headEnd type="none" w="med" len="med"/>
+                      <a:tailEnd type="none" w="med" len="med"/>
+                    </a:lnL>
+                    <a:lnR w="9525" cap="flat" cmpd="sng" algn="ctr">
+                      <a:solidFill>
+                        <a:srgbClr val="38383E"/>
+                      </a:solidFill>
+                      <a:prstDash val="solid"/>
+                      <a:round/>
+                      <a:headEnd type="none" w="med" len="med"/>
+                      <a:tailEnd type="none" w="med" len="med"/>
+                    </a:lnR>
+                    <a:lnT w="9525" cap="flat" cmpd="sng" algn="ctr">
+                      <a:solidFill>
+                        <a:srgbClr val="38383E"/>
+                      </a:solidFill>
+                      <a:prstDash val="solid"/>
+                      <a:round/>
+                      <a:headEnd type="none" w="med" len="med"/>
+                      <a:tailEnd type="none" w="med" len="med"/>
+                    </a:lnT>
+                    <a:lnB w="9525" cap="flat" cmpd="sng" algn="ctr">
+                      <a:solidFill>
+                        <a:srgbClr val="38383E"/>
+                      </a:solidFill>
+                      <a:prstDash val="solid"/>
+                      <a:round/>
+                      <a:headEnd type="none" w="med" len="med"/>
+                      <a:tailEnd type="none" w="med" len="med"/>
+                    </a:lnB>
+                    <a:solidFill>
+                      <a:srgbClr val="121214"/>
+                    </a:solidFill>
+                  </a:tcPr>
+                </a:tc>
+                <a:tc>
+                  <a:txBody>
+                    <a:bodyPr/>
+                    <a:lstStyle/>
+                    <a:p>
+                      <a:pPr algn="ctr" indent="0" marL="0">
+                        <a:buNone/>
+                      </a:pPr>
+                      <a:r>
+                        <a:rPr lang="en-US" sz="1100" b="1" dirty="0">
+                          <a:solidFill>
+                            <a:srgbClr val="A8ADB8"/>
+                          </a:solidFill>
+                          <a:latin typeface="Consolas" pitchFamily="34" charset="0"/>
+                          <a:ea typeface="Consolas" pitchFamily="34" charset="-122"/>
+                          <a:cs typeface="Consolas" pitchFamily="34" charset="-120"/>
+                        </a:rPr>
+                        <a:t>formal</a:t>
+                      </a:r>
+                      <a:endParaRPr lang="en-US" sz="1100" dirty="0">
+                        <a:latin typeface="Consolas" charset="0"/>
+                        <a:ea typeface="Consolas" charset="0"/>
+                        <a:cs typeface="Consolas" charset="0"/>
+                      </a:endParaRPr>
+                    </a:p>
+                  </a:txBody>
+                  <a:tcPr marL="91440" marR="91440" marT="45720" marB="45720" anchor="ctr">
+                    <a:lnL w="9525" cap="flat" cmpd="sng" algn="ctr">
+                      <a:solidFill>
+                        <a:srgbClr val="38383E"/>
+                      </a:solidFill>
+                      <a:prstDash val="solid"/>
+                      <a:round/>
+                      <a:headEnd type="none" w="med" len="med"/>
+                      <a:tailEnd type="none" w="med" len="med"/>
+                    </a:lnL>
+                    <a:lnR w="9525" cap="flat" cmpd="sng" algn="ctr">
+                      <a:solidFill>
+                        <a:srgbClr val="38383E"/>
+                      </a:solidFill>
+                      <a:prstDash val="solid"/>
+                      <a:round/>
+                      <a:headEnd type="none" w="med" len="med"/>
+                      <a:tailEnd type="none" w="med" len="med"/>
+                    </a:lnR>
+                    <a:lnT w="9525" cap="flat" cmpd="sng" algn="ctr">
+                      <a:solidFill>
+                        <a:srgbClr val="38383E"/>
+                      </a:solidFill>
+                      <a:prstDash val="solid"/>
+                      <a:round/>
+                      <a:headEnd type="none" w="med" len="med"/>
+                      <a:tailEnd type="none" w="med" len="med"/>
+                    </a:lnT>
+                    <a:lnB w="9525" cap="flat" cmpd="sng" algn="ctr">
+                      <a:solidFill>
+                        <a:srgbClr val="38383E"/>
+                      </a:solidFill>
+                      <a:prstDash val="solid"/>
+                      <a:round/>
+                      <a:headEnd type="none" w="med" len="med"/>
+                      <a:tailEnd type="none" w="med" len="med"/>
+                    </a:lnB>
+                    <a:solidFill>
+                      <a:srgbClr val="121214"/>
+                    </a:solidFill>
+                  </a:tcPr>
+                </a:tc>
+                <a:tc>
+                  <a:txBody>
+                    <a:bodyPr/>
+                    <a:lstStyle/>
+                    <a:p>
+                      <a:pPr algn="ctr" indent="0" marL="0">
+                        <a:buNone/>
+                      </a:pPr>
+                      <a:r>
+                        <a:rPr lang="en-US" sz="1100" b="1" dirty="0">
+                          <a:solidFill>
+                            <a:srgbClr val="A8ADB8"/>
+                          </a:solidFill>
+                          <a:latin typeface="Consolas" pitchFamily="34" charset="0"/>
+                          <a:ea typeface="Consolas" pitchFamily="34" charset="-122"/>
+                          <a:cs typeface="Consolas" pitchFamily="34" charset="-120"/>
+                        </a:rPr>
+                        <a:t>sarcastic</a:t>
+                      </a:r>
+                      <a:endParaRPr lang="en-US" sz="1100" dirty="0">
+                        <a:latin typeface="Consolas" charset="0"/>
+                        <a:ea typeface="Consolas" charset="0"/>
+                        <a:cs typeface="Consolas" charset="0"/>
+                      </a:endParaRPr>
+                    </a:p>
+                  </a:txBody>
+                  <a:tcPr marL="91440" marR="91440" marT="45720" marB="45720" anchor="ctr">
+                    <a:lnL w="9525" cap="flat" cmpd="sng" algn="ctr">
+                      <a:solidFill>
+                        <a:srgbClr val="38383E"/>
+                      </a:solidFill>
+                      <a:prstDash val="solid"/>
+                      <a:round/>
+                      <a:headEnd type="none" w="med" len="med"/>
+                      <a:tailEnd type="none" w="med" len="med"/>
+                    </a:lnL>
+                    <a:lnR w="9525" cap="flat" cmpd="sng" algn="ctr">
+                      <a:solidFill>
+                        <a:srgbClr val="38383E"/>
+                      </a:solidFill>
+                      <a:prstDash val="solid"/>
+                      <a:round/>
+                      <a:headEnd type="none" w="med" len="med"/>
+                      <a:tailEnd type="none" w="med" len="med"/>
+                    </a:lnR>
+                    <a:lnT w="9525" cap="flat" cmpd="sng" algn="ctr">
+                      <a:solidFill>
+                        <a:srgbClr val="38383E"/>
+                      </a:solidFill>
+                      <a:prstDash val="solid"/>
+                      <a:round/>
+                      <a:headEnd type="none" w="med" len="med"/>
+                      <a:tailEnd type="none" w="med" len="med"/>
+                    </a:lnT>
+                    <a:lnB w="9525" cap="flat" cmpd="sng" algn="ctr">
+                      <a:solidFill>
+                        <a:srgbClr val="38383E"/>
+                      </a:solidFill>
+                      <a:prstDash val="solid"/>
+                      <a:round/>
+                      <a:headEnd type="none" w="med" len="med"/>
+                      <a:tailEnd type="none" w="med" len="med"/>
+                    </a:lnB>
+                    <a:solidFill>
+                      <a:srgbClr val="121214"/>
+                    </a:solidFill>
+                  </a:tcPr>
+                </a:tc>
+                <a:tc>
+                  <a:txBody>
+                    <a:bodyPr/>
+                    <a:lstStyle/>
+                    <a:p>
+                      <a:pPr algn="ctr" indent="0" marL="0">
+                        <a:buNone/>
+                      </a:pPr>
+                      <a:r>
+                        <a:rPr lang="en-US" sz="1100" b="1" dirty="0">
+                          <a:solidFill>
+                            <a:srgbClr val="A8ADB8"/>
+                          </a:solidFill>
+                          <a:latin typeface="Consolas" pitchFamily="34" charset="0"/>
+                          <a:ea typeface="Consolas" pitchFamily="34" charset="-122"/>
+                          <a:cs typeface="Consolas" pitchFamily="34" charset="-120"/>
+                        </a:rPr>
+                        <a:t>hum_tech</a:t>
+                      </a:r>
+                      <a:endParaRPr lang="en-US" sz="1100" dirty="0">
+                        <a:latin typeface="Consolas" charset="0"/>
+                        <a:ea typeface="Consolas" charset="0"/>
+                        <a:cs typeface="Consolas" charset="0"/>
+                      </a:endParaRPr>
+                    </a:p>
+                  </a:txBody>
+                  <a:tcPr marL="91440" marR="91440" marT="45720" marB="45720" anchor="ctr">
+                    <a:lnL w="9525" cap="flat" cmpd="sng" algn="ctr">
+                      <a:solidFill>
+                        <a:srgbClr val="38383E"/>
+                      </a:solidFill>
+                      <a:prstDash val="solid"/>
+                      <a:round/>
+                      <a:headEnd type="none" w="med" len="med"/>
+                      <a:tailEnd type="none" w="med" len="med"/>
+                    </a:lnL>
+                    <a:lnR w="9525" cap="flat" cmpd="sng" algn="ctr">
+                      <a:solidFill>
+                        <a:srgbClr val="38383E"/>
+                      </a:solidFill>
+                      <a:prstDash val="solid"/>
+                      <a:round/>
+                      <a:headEnd type="none" w="med" len="med"/>
+                      <a:tailEnd type="none" w="med" len="med"/>
+                    </a:lnR>
+                    <a:lnT w="9525" cap="flat" cmpd="sng" algn="ctr">
+                      <a:solidFill>
+                        <a:srgbClr val="38383E"/>
+                      </a:solidFill>
+                      <a:prstDash val="solid"/>
+                      <a:round/>
+                      <a:headEnd type="none" w="med" len="med"/>
+                      <a:tailEnd type="none" w="med" len="med"/>
+                    </a:lnT>
+                    <a:lnB w="9525" cap="flat" cmpd="sng" algn="ctr">
+                      <a:solidFill>
+                        <a:srgbClr val="38383E"/>
+                      </a:solidFill>
+                      <a:prstDash val="solid"/>
+                      <a:round/>
+                      <a:headEnd type="none" w="med" len="med"/>
+                      <a:tailEnd type="none" w="med" len="med"/>
+                    </a:lnB>
+                    <a:solidFill>
+                      <a:srgbClr val="121214"/>
+                    </a:solidFill>
+                  </a:tcPr>
+                </a:tc>
+                <a:tc>
+                  <a:txBody>
+                    <a:bodyPr/>
+                    <a:lstStyle/>
+                    <a:p>
+                      <a:pPr algn="ctr" indent="0" marL="0">
+                        <a:buNone/>
+                      </a:pPr>
+                      <a:r>
+                        <a:rPr lang="en-US" sz="1100" b="1" dirty="0">
+                          <a:solidFill>
+                            <a:srgbClr val="A8ADB8"/>
+                          </a:solidFill>
+                          <a:latin typeface="Consolas" pitchFamily="34" charset="0"/>
+                          <a:ea typeface="Consolas" pitchFamily="34" charset="-122"/>
+                          <a:cs typeface="Consolas" pitchFamily="34" charset="-120"/>
+                        </a:rPr>
+                        <a:t>hum_non_tech</a:t>
+                      </a:r>
+                      <a:endParaRPr lang="en-US" sz="1100" dirty="0">
+                        <a:latin typeface="Consolas" charset="0"/>
+                        <a:ea typeface="Consolas" charset="0"/>
+                        <a:cs typeface="Consolas" charset="0"/>
+                      </a:endParaRPr>
+                    </a:p>
+                  </a:txBody>
+                  <a:tcPr marL="91440" marR="91440" marT="45720" marB="45720" anchor="ctr">
+                    <a:lnL w="9525" cap="flat" cmpd="sng" algn="ctr">
+                      <a:solidFill>
+                        <a:srgbClr val="38383E"/>
+                      </a:solidFill>
+                      <a:prstDash val="solid"/>
+                      <a:round/>
+                      <a:headEnd type="none" w="med" len="med"/>
+                      <a:tailEnd type="none" w="med" len="med"/>
+                    </a:lnL>
+                    <a:lnR w="9525" cap="flat" cmpd="sng" algn="ctr">
+                      <a:solidFill>
+                        <a:srgbClr val="38383E"/>
+                      </a:solidFill>
+                      <a:prstDash val="solid"/>
+                      <a:round/>
+                      <a:headEnd type="none" w="med" len="med"/>
+                      <a:tailEnd type="none" w="med" len="med"/>
+                    </a:lnR>
+                    <a:lnT w="9525" cap="flat" cmpd="sng" algn="ctr">
+                      <a:solidFill>
+                        <a:srgbClr val="38383E"/>
+                      </a:solidFill>
+                      <a:prstDash val="solid"/>
+                      <a:round/>
+                      <a:headEnd type="none" w="med" len="med"/>
+                      <a:tailEnd type="none" w="med" len="med"/>
+                    </a:lnT>
+                    <a:lnB w="9525" cap="flat" cmpd="sng" algn="ctr">
+                      <a:solidFill>
+                        <a:srgbClr val="38383E"/>
+                      </a:solidFill>
+                      <a:prstDash val="solid"/>
+                      <a:round/>
+                      <a:headEnd type="none" w="med" len="med"/>
+                      <a:tailEnd type="none" w="med" len="med"/>
+                    </a:lnB>
+                    <a:solidFill>
+                      <a:srgbClr val="121214"/>
+                    </a:solidFill>
+                  </a:tcPr>
+                </a:tc>
+                <a:tc>
+                  <a:txBody>
+                    <a:bodyPr/>
+                    <a:lstStyle/>
+                    <a:p>
+                      <a:pPr algn="ctr" indent="0" marL="0">
+                        <a:buNone/>
+                      </a:pPr>
+                      <a:r>
+                        <a:rPr lang="en-US" sz="1100" b="1" dirty="0">
+                          <a:solidFill>
+                            <a:srgbClr val="A8ADB8"/>
+                          </a:solidFill>
+                          <a:latin typeface="Consolas" pitchFamily="34" charset="0"/>
+                          <a:ea typeface="Consolas" pitchFamily="34" charset="-122"/>
+                          <a:cs typeface="Consolas" pitchFamily="34" charset="-120"/>
+                        </a:rPr>
+                        <a:t>ALL</a:t>
+                      </a:r>
+                      <a:endParaRPr lang="en-US" sz="1100" dirty="0">
+                        <a:latin typeface="Consolas" charset="0"/>
+                        <a:ea typeface="Consolas" charset="0"/>
+                        <a:cs typeface="Consolas" charset="0"/>
+                      </a:endParaRPr>
+                    </a:p>
+                  </a:txBody>
+                  <a:tcPr marL="91440" marR="91440" marT="45720" marB="45720" anchor="ctr">
+                    <a:lnL w="9525" cap="flat" cmpd="sng" algn="ctr">
+                      <a:solidFill>
+                        <a:srgbClr val="38383E"/>
+                      </a:solidFill>
+                      <a:prstDash val="solid"/>
+                      <a:round/>
+                      <a:headEnd type="none" w="med" len="med"/>
+                      <a:tailEnd type="none" w="med" len="med"/>
+                    </a:lnL>
+                    <a:lnR w="9525" cap="flat" cmpd="sng" algn="ctr">
+                      <a:solidFill>
+                        <a:srgbClr val="38383E"/>
+                      </a:solidFill>
+                      <a:prstDash val="solid"/>
+                      <a:round/>
+                      <a:headEnd type="none" w="med" len="med"/>
+                      <a:tailEnd type="none" w="med" len="med"/>
+                    </a:lnR>
+                    <a:lnT w="9525" cap="flat" cmpd="sng" algn="ctr">
+                      <a:solidFill>
+                        <a:srgbClr val="38383E"/>
+                      </a:solidFill>
+                      <a:prstDash val="solid"/>
+                      <a:round/>
+                      <a:headEnd type="none" w="med" len="med"/>
+                      <a:tailEnd type="none" w="med" len="med"/>
+                    </a:lnT>
+                    <a:lnB w="9525" cap="flat" cmpd="sng" algn="ctr">
+                      <a:solidFill>
+                        <a:srgbClr val="38383E"/>
+                      </a:solidFill>
+                      <a:prstDash val="solid"/>
+                      <a:round/>
+                      <a:headEnd type="none" w="med" len="med"/>
+                      <a:tailEnd type="none" w="med" len="med"/>
+                    </a:lnB>
+                    <a:solidFill>
+                      <a:srgbClr val="121214"/>
+                    </a:solidFill>
+                  </a:tcPr>
+                </a:tc>
+              </a:tr>
+              <a:tr h="310896">
+                <a:tc>
+                  <a:txBody>
+                    <a:bodyPr/>
+                    <a:lstStyle/>
+                    <a:p>
+                      <a:pPr algn="ctr" indent="0" marL="0">
+                        <a:buNone/>
+                      </a:pPr>
+                      <a:r>
+                        <a:rPr lang="en-US" sz="1150" b="1" dirty="0">
+                          <a:solidFill>
+                            <a:srgbClr val="FFFFFF"/>
+                          </a:solidFill>
+                          <a:latin typeface="Consolas" pitchFamily="34" charset="0"/>
+                          <a:ea typeface="Consolas" pitchFamily="34" charset="-122"/>
+                          <a:cs typeface="Consolas" pitchFamily="34" charset="-120"/>
+                        </a:rPr>
+                        <a:t>Kimi K2.6 prompted</a:t>
+                      </a:r>
+                      <a:endParaRPr lang="en-US" sz="1150" dirty="0">
+                        <a:latin typeface="Consolas" charset="0"/>
+                        <a:ea typeface="Consolas" charset="0"/>
+                        <a:cs typeface="Consolas" charset="0"/>
+                      </a:endParaRPr>
+                    </a:p>
+                  </a:txBody>
+                  <a:tcPr marL="91440" marR="91440" marT="45720" marB="45720" anchor="ctr">
+                    <a:lnL w="9525" cap="flat" cmpd="sng" algn="ctr">
+                      <a:solidFill>
+                        <a:srgbClr val="38383E"/>
+                      </a:solidFill>
+                      <a:prstDash val="solid"/>
+                      <a:round/>
+                      <a:headEnd type="none" w="med" len="med"/>
+                      <a:tailEnd type="none" w="med" len="med"/>
+                    </a:lnL>
+                    <a:lnR w="9525" cap="flat" cmpd="sng" algn="ctr">
+                      <a:solidFill>
+                        <a:srgbClr val="38383E"/>
+                      </a:solidFill>
+                      <a:prstDash val="solid"/>
+                      <a:round/>
+                      <a:headEnd type="none" w="med" len="med"/>
+                      <a:tailEnd type="none" w="med" len="med"/>
+                    </a:lnR>
+                    <a:lnT w="9525" cap="flat" cmpd="sng" algn="ctr">
+                      <a:solidFill>
+                        <a:srgbClr val="38383E"/>
+                      </a:solidFill>
+                      <a:prstDash val="solid"/>
+                      <a:round/>
+                      <a:headEnd type="none" w="med" len="med"/>
+                      <a:tailEnd type="none" w="med" len="med"/>
+                    </a:lnT>
+                    <a:lnB w="9525" cap="flat" cmpd="sng" algn="ctr">
+                      <a:solidFill>
+                        <a:srgbClr val="38383E"/>
+                      </a:solidFill>
+                      <a:prstDash val="solid"/>
+                      <a:round/>
+                      <a:headEnd type="none" w="med" len="med"/>
+                      <a:tailEnd type="none" w="med" len="med"/>
+                    </a:lnB>
+                    <a:solidFill>
+                      <a:srgbClr val="1F1F23"/>
+                    </a:solidFill>
+                  </a:tcPr>
+                </a:tc>
+                <a:tc>
+                  <a:txBody>
+                    <a:bodyPr/>
+                    <a:lstStyle/>
+                    <a:p>
+                      <a:pPr algn="ctr" indent="0" marL="0">
+                        <a:buNone/>
+                      </a:pPr>
+                      <a:r>
+                        <a:rPr lang="en-US" sz="1150" dirty="0">
+                          <a:solidFill>
+                            <a:srgbClr val="FFFFFF"/>
+                          </a:solidFill>
+                          <a:latin typeface="Consolas" pitchFamily="34" charset="0"/>
+                          <a:ea typeface="Consolas" pitchFamily="34" charset="-122"/>
+                          <a:cs typeface="Consolas" pitchFamily="34" charset="-120"/>
+                        </a:rPr>
+                        <a:t>8.92</a:t>
+                      </a:r>
+                      <a:endParaRPr lang="en-US" sz="1150" dirty="0">
+                        <a:latin typeface="Consolas" charset="0"/>
+                        <a:ea typeface="Consolas" charset="0"/>
+                        <a:cs typeface="Consolas" charset="0"/>
+                      </a:endParaRPr>
+                    </a:p>
+                  </a:txBody>
+                  <a:tcPr marL="91440" marR="91440" marT="45720" marB="45720" anchor="ctr">
+                    <a:lnL w="9525" cap="flat" cmpd="sng" algn="ctr">
+                      <a:solidFill>
+                        <a:srgbClr val="38383E"/>
+                      </a:solidFill>
+                      <a:prstDash val="solid"/>
+                      <a:round/>
+                      <a:headEnd type="none" w="med" len="med"/>
+                      <a:tailEnd type="none" w="med" len="med"/>
+                    </a:lnL>
+                    <a:lnR w="9525" cap="flat" cmpd="sng" algn="ctr">
+                      <a:solidFill>
+                        <a:srgbClr val="38383E"/>
+                      </a:solidFill>
+                      <a:prstDash val="solid"/>
+                      <a:round/>
+                      <a:headEnd type="none" w="med" len="med"/>
+                      <a:tailEnd type="none" w="med" len="med"/>
+                    </a:lnR>
+                    <a:lnT w="9525" cap="flat" cmpd="sng" algn="ctr">
+                      <a:solidFill>
+                        <a:srgbClr val="38383E"/>
+                      </a:solidFill>
+                      <a:prstDash val="solid"/>
+                      <a:round/>
+                      <a:headEnd type="none" w="med" len="med"/>
+                      <a:tailEnd type="none" w="med" len="med"/>
+                    </a:lnT>
+                    <a:lnB w="9525" cap="flat" cmpd="sng" algn="ctr">
+                      <a:solidFill>
+                        <a:srgbClr val="38383E"/>
+                      </a:solidFill>
+                      <a:prstDash val="solid"/>
+                      <a:round/>
+                      <a:headEnd type="none" w="med" len="med"/>
+                      <a:tailEnd type="none" w="med" len="med"/>
+                    </a:lnB>
+                    <a:solidFill>
+                      <a:srgbClr val="1F1F23"/>
+                    </a:solidFill>
+                  </a:tcPr>
+                </a:tc>
+                <a:tc>
+                  <a:txBody>
+                    <a:bodyPr/>
+                    <a:lstStyle/>
+                    <a:p>
+                      <a:pPr algn="ctr" indent="0" marL="0">
+                        <a:buNone/>
+                      </a:pPr>
+                      <a:r>
+                        <a:rPr lang="en-US" sz="1150" dirty="0">
+                          <a:solidFill>
+                            <a:srgbClr val="FFFFFF"/>
+                          </a:solidFill>
+                          <a:latin typeface="Consolas" pitchFamily="34" charset="0"/>
+                          <a:ea typeface="Consolas" pitchFamily="34" charset="-122"/>
+                          <a:cs typeface="Consolas" pitchFamily="34" charset="-120"/>
+                        </a:rPr>
+                        <a:t>7.72</a:t>
+                      </a:r>
+                      <a:endParaRPr lang="en-US" sz="1150" dirty="0">
+                        <a:latin typeface="Consolas" charset="0"/>
+                        <a:ea typeface="Consolas" charset="0"/>
+                        <a:cs typeface="Consolas" charset="0"/>
+                      </a:endParaRPr>
+                    </a:p>
+                  </a:txBody>
+                  <a:tcPr marL="91440" marR="91440" marT="45720" marB="45720" anchor="ctr">
+                    <a:lnL w="9525" cap="flat" cmpd="sng" algn="ctr">
+                      <a:solidFill>
+                        <a:srgbClr val="38383E"/>
+                      </a:solidFill>
+                      <a:prstDash val="solid"/>
+                      <a:round/>
+                      <a:headEnd type="none" w="med" len="med"/>
+                      <a:tailEnd type="none" w="med" len="med"/>
+                    </a:lnL>
+                    <a:lnR w="9525" cap="flat" cmpd="sng" algn="ctr">
+                      <a:solidFill>
+                        <a:srgbClr val="38383E"/>
+                      </a:solidFill>
+                      <a:prstDash val="solid"/>
+                      <a:round/>
+                      <a:headEnd type="none" w="med" len="med"/>
+                      <a:tailEnd type="none" w="med" len="med"/>
+                    </a:lnR>
+                    <a:lnT w="9525" cap="flat" cmpd="sng" algn="ctr">
+                      <a:solidFill>
+                        <a:srgbClr val="38383E"/>
+                      </a:solidFill>
+                      <a:prstDash val="solid"/>
+                      <a:round/>
+                      <a:headEnd type="none" w="med" len="med"/>
+                      <a:tailEnd type="none" w="med" len="med"/>
+                    </a:lnT>
+                    <a:lnB w="9525" cap="flat" cmpd="sng" algn="ctr">
+                      <a:solidFill>
+                        <a:srgbClr val="38383E"/>
+                      </a:solidFill>
+                      <a:prstDash val="solid"/>
+                      <a:round/>
+                      <a:headEnd type="none" w="med" len="med"/>
+                      <a:tailEnd type="none" w="med" len="med"/>
+                    </a:lnB>
+                    <a:solidFill>
+                      <a:srgbClr val="1F1F23"/>
+                    </a:solidFill>
+                  </a:tcPr>
+                </a:tc>
+                <a:tc>
+                  <a:txBody>
+                    <a:bodyPr/>
+                    <a:lstStyle/>
+                    <a:p>
+                      <a:pPr algn="ctr" indent="0" marL="0">
+                        <a:buNone/>
+                      </a:pPr>
+                      <a:r>
+                        <a:rPr lang="en-US" sz="1150" dirty="0">
+                          <a:solidFill>
+                            <a:srgbClr val="FFFFFF"/>
+                          </a:solidFill>
+                          <a:latin typeface="Consolas" pitchFamily="34" charset="0"/>
+                          <a:ea typeface="Consolas" pitchFamily="34" charset="-122"/>
+                          <a:cs typeface="Consolas" pitchFamily="34" charset="-120"/>
+                        </a:rPr>
+                        <a:t>8.23</a:t>
+                      </a:r>
+                      <a:endParaRPr lang="en-US" sz="1150" dirty="0">
+                        <a:latin typeface="Consolas" charset="0"/>
+                        <a:ea typeface="Consolas" charset="0"/>
+                        <a:cs typeface="Consolas" charset="0"/>
+                      </a:endParaRPr>
+                    </a:p>
+                  </a:txBody>
+                  <a:tcPr marL="91440" marR="91440" marT="45720" marB="45720" anchor="ctr">
+                    <a:lnL w="9525" cap="flat" cmpd="sng" algn="ctr">
+                      <a:solidFill>
+                        <a:srgbClr val="38383E"/>
+                      </a:solidFill>
+                      <a:prstDash val="solid"/>
+                      <a:round/>
+                      <a:headEnd type="none" w="med" len="med"/>
+                      <a:tailEnd type="none" w="med" len="med"/>
+                    </a:lnL>
+                    <a:lnR w="9525" cap="flat" cmpd="sng" algn="ctr">
+                      <a:solidFill>
+                        <a:srgbClr val="38383E"/>
+                      </a:solidFill>
+                      <a:prstDash val="solid"/>
+                      <a:round/>
+                      <a:headEnd type="none" w="med" len="med"/>
+                      <a:tailEnd type="none" w="med" len="med"/>
+                    </a:lnR>
+                    <a:lnT w="9525" cap="flat" cmpd="sng" algn="ctr">
+                      <a:solidFill>
+                        <a:srgbClr val="38383E"/>
+                      </a:solidFill>
+                      <a:prstDash val="solid"/>
+                      <a:round/>
+                      <a:headEnd type="none" w="med" len="med"/>
+                      <a:tailEnd type="none" w="med" len="med"/>
+                    </a:lnT>
+                    <a:lnB w="9525" cap="flat" cmpd="sng" algn="ctr">
+                      <a:solidFill>
+                        <a:srgbClr val="38383E"/>
+                      </a:solidFill>
+                      <a:prstDash val="solid"/>
+                      <a:round/>
+                      <a:headEnd type="none" w="med" len="med"/>
+                      <a:tailEnd type="none" w="med" len="med"/>
+                    </a:lnB>
+                    <a:solidFill>
+                      <a:srgbClr val="1F1F23"/>
+                    </a:solidFill>
+                  </a:tcPr>
+                </a:tc>
+                <a:tc>
+                  <a:txBody>
+                    <a:bodyPr/>
+                    <a:lstStyle/>
+                    <a:p>
+                      <a:pPr algn="ctr" indent="0" marL="0">
+                        <a:buNone/>
+                      </a:pPr>
+                      <a:r>
+                        <a:rPr lang="en-US" sz="1150" dirty="0">
+                          <a:solidFill>
+                            <a:srgbClr val="FFFFFF"/>
+                          </a:solidFill>
+                          <a:latin typeface="Consolas" pitchFamily="34" charset="0"/>
+                          <a:ea typeface="Consolas" pitchFamily="34" charset="-122"/>
+                          <a:cs typeface="Consolas" pitchFamily="34" charset="-120"/>
+                        </a:rPr>
+                        <a:t>7.87</a:t>
+                      </a:r>
+                      <a:endParaRPr lang="en-US" sz="1150" dirty="0">
+                        <a:latin typeface="Consolas" charset="0"/>
+                        <a:ea typeface="Consolas" charset="0"/>
+                        <a:cs typeface="Consolas" charset="0"/>
+                      </a:endParaRPr>
+                    </a:p>
+                  </a:txBody>
+                  <a:tcPr marL="91440" marR="91440" marT="45720" marB="45720" anchor="ctr">
+                    <a:lnL w="9525" cap="flat" cmpd="sng" algn="ctr">
+                      <a:solidFill>
+                        <a:srgbClr val="38383E"/>
+                      </a:solidFill>
+                      <a:prstDash val="solid"/>
+                      <a:round/>
+                      <a:headEnd type="none" w="med" len="med"/>
+                      <a:tailEnd type="none" w="med" len="med"/>
+                    </a:lnL>
+                    <a:lnR w="9525" cap="flat" cmpd="sng" algn="ctr">
+                      <a:solidFill>
+                        <a:srgbClr val="38383E"/>
+                      </a:solidFill>
+                      <a:prstDash val="solid"/>
+                      <a:round/>
+                      <a:headEnd type="none" w="med" len="med"/>
+                      <a:tailEnd type="none" w="med" len="med"/>
+                    </a:lnR>
+                    <a:lnT w="9525" cap="flat" cmpd="sng" algn="ctr">
+                      <a:solidFill>
+                        <a:srgbClr val="38383E"/>
+                      </a:solidFill>
+                      <a:prstDash val="solid"/>
+                      <a:round/>
+                      <a:headEnd type="none" w="med" len="med"/>
+                      <a:tailEnd type="none" w="med" len="med"/>
+                    </a:lnT>
+                    <a:lnB w="9525" cap="flat" cmpd="sng" algn="ctr">
+                      <a:solidFill>
+                        <a:srgbClr val="38383E"/>
+                      </a:solidFill>
+                      <a:prstDash val="solid"/>
+                      <a:round/>
+                      <a:headEnd type="none" w="med" len="med"/>
+                      <a:tailEnd type="none" w="med" len="med"/>
+                    </a:lnB>
+                    <a:solidFill>
+                      <a:srgbClr val="1F1F23"/>
+                    </a:solidFill>
+                  </a:tcPr>
+                </a:tc>
+                <a:tc>
+                  <a:txBody>
+                    <a:bodyPr/>
+                    <a:lstStyle/>
+                    <a:p>
+                      <a:pPr algn="ctr" indent="0" marL="0">
+                        <a:buNone/>
+                      </a:pPr>
+                      <a:r>
+                        <a:rPr lang="en-US" sz="1150" b="1" dirty="0">
+                          <a:solidFill>
+                            <a:srgbClr val="FFFFFF"/>
+                          </a:solidFill>
+                          <a:latin typeface="Consolas" pitchFamily="34" charset="0"/>
+                          <a:ea typeface="Consolas" pitchFamily="34" charset="-122"/>
+                          <a:cs typeface="Consolas" pitchFamily="34" charset="-120"/>
+                        </a:rPr>
+                        <a:t>8.18</a:t>
+                      </a:r>
+                      <a:endParaRPr lang="en-US" sz="1150" dirty="0">
+                        <a:latin typeface="Consolas" charset="0"/>
+                        <a:ea typeface="Consolas" charset="0"/>
+                        <a:cs typeface="Consolas" charset="0"/>
+                      </a:endParaRPr>
+                    </a:p>
+                  </a:txBody>
+                  <a:tcPr marL="91440" marR="91440" marT="45720" marB="45720" anchor="ctr">
+                    <a:lnL w="9525" cap="flat" cmpd="sng" algn="ctr">
+                      <a:solidFill>
+                        <a:srgbClr val="38383E"/>
+                      </a:solidFill>
+                      <a:prstDash val="solid"/>
+                      <a:round/>
+                      <a:headEnd type="none" w="med" len="med"/>
+                      <a:tailEnd type="none" w="med" len="med"/>
+                    </a:lnL>
+                    <a:lnR w="9525" cap="flat" cmpd="sng" algn="ctr">
+                      <a:solidFill>
+                        <a:srgbClr val="38383E"/>
+                      </a:solidFill>
+                      <a:prstDash val="solid"/>
+                      <a:round/>
+                      <a:headEnd type="none" w="med" len="med"/>
+                      <a:tailEnd type="none" w="med" len="med"/>
+                    </a:lnR>
+                    <a:lnT w="9525" cap="flat" cmpd="sng" algn="ctr">
+                      <a:solidFill>
+                        <a:srgbClr val="38383E"/>
+                      </a:solidFill>
+                      <a:prstDash val="solid"/>
+                      <a:round/>
+                      <a:headEnd type="none" w="med" len="med"/>
+                      <a:tailEnd type="none" w="med" len="med"/>
+                    </a:lnT>
+                    <a:lnB w="9525" cap="flat" cmpd="sng" algn="ctr">
+                      <a:solidFill>
+                        <a:srgbClr val="38383E"/>
+                      </a:solidFill>
+                      <a:prstDash val="solid"/>
+                      <a:round/>
+                      <a:headEnd type="none" w="med" len="med"/>
+                      <a:tailEnd type="none" w="med" len="med"/>
+                    </a:lnB>
+                    <a:solidFill>
+                      <a:srgbClr val="1F1F23"/>
+                    </a:solidFill>
+                  </a:tcPr>
+                </a:tc>
+              </a:tr>
+              <a:tr h="310896">
+                <a:tc>
+                  <a:txBody>
+                    <a:bodyPr/>
+                    <a:lstStyle/>
+                    <a:p>
+                      <a:pPr algn="ctr" indent="0" marL="0">
+                        <a:buNone/>
+                      </a:pPr>
+                      <a:r>
+                        <a:rPr lang="en-US" sz="1150" b="1" dirty="0">
+                          <a:solidFill>
+                            <a:srgbClr val="FFFFFF"/>
+                          </a:solidFill>
+                          <a:latin typeface="Consolas" pitchFamily="34" charset="0"/>
+                          <a:ea typeface="Consolas" pitchFamily="34" charset="-122"/>
+                          <a:cs typeface="Consolas" pitchFamily="34" charset="-120"/>
+                        </a:rPr>
+                        <a:t>Gemma 4B base</a:t>
+                      </a:r>
+                      <a:endParaRPr lang="en-US" sz="1150" dirty="0">
+                        <a:latin typeface="Consolas" charset="0"/>
+                        <a:ea typeface="Consolas" charset="0"/>
+                        <a:cs typeface="Consolas" charset="0"/>
+                      </a:endParaRPr>
+                    </a:p>
+                  </a:txBody>
+                  <a:tcPr marL="91440" marR="91440" marT="45720" marB="45720" anchor="ctr">
+                    <a:lnL w="9525" cap="flat" cmpd="sng" algn="ctr">
+                      <a:solidFill>
+                        <a:srgbClr val="38383E"/>
+                      </a:solidFill>
+                      <a:prstDash val="solid"/>
+                      <a:round/>
+                      <a:headEnd type="none" w="med" len="med"/>
+                      <a:tailEnd type="none" w="med" len="med"/>
+                    </a:lnL>
+                    <a:lnR w="9525" cap="flat" cmpd="sng" algn="ctr">
+                      <a:solidFill>
+                        <a:srgbClr val="38383E"/>
+                      </a:solidFill>
+                      <a:prstDash val="solid"/>
+                      <a:round/>
+                      <a:headEnd type="none" w="med" len="med"/>
+                      <a:tailEnd type="none" w="med" len="med"/>
+                    </a:lnR>
+                    <a:lnT w="9525" cap="flat" cmpd="sng" algn="ctr">
+                      <a:solidFill>
+                        <a:srgbClr val="38383E"/>
+                      </a:solidFill>
+                      <a:prstDash val="solid"/>
+                      <a:round/>
+                      <a:headEnd type="none" w="med" len="med"/>
+                      <a:tailEnd type="none" w="med" len="med"/>
+                    </a:lnT>
+                    <a:lnB w="9525" cap="flat" cmpd="sng" algn="ctr">
+                      <a:solidFill>
+                        <a:srgbClr val="38383E"/>
+                      </a:solidFill>
+                      <a:prstDash val="solid"/>
+                      <a:round/>
+                      <a:headEnd type="none" w="med" len="med"/>
+                      <a:tailEnd type="none" w="med" len="med"/>
+                    </a:lnB>
+                    <a:solidFill>
+                      <a:srgbClr val="1F1F23"/>
+                    </a:solidFill>
+                  </a:tcPr>
+                </a:tc>
+                <a:tc>
+                  <a:txBody>
+                    <a:bodyPr/>
+                    <a:lstStyle/>
+                    <a:p>
+                      <a:pPr algn="ctr" indent="0" marL="0">
+                        <a:buNone/>
+                      </a:pPr>
+                      <a:r>
+                        <a:rPr lang="en-US" sz="1150" dirty="0">
+                          <a:solidFill>
+                            <a:srgbClr val="FFFFFF"/>
+                          </a:solidFill>
+                          <a:latin typeface="Consolas" pitchFamily="34" charset="0"/>
+                          <a:ea typeface="Consolas" pitchFamily="34" charset="-122"/>
+                          <a:cs typeface="Consolas" pitchFamily="34" charset="-120"/>
+                        </a:rPr>
+                        <a:t>7.88</a:t>
+                      </a:r>
+                      <a:endParaRPr lang="en-US" sz="1150" dirty="0">
+                        <a:latin typeface="Consolas" charset="0"/>
+                        <a:ea typeface="Consolas" charset="0"/>
+                        <a:cs typeface="Consolas" charset="0"/>
+                      </a:endParaRPr>
+                    </a:p>
+                  </a:txBody>
+                  <a:tcPr marL="91440" marR="91440" marT="45720" marB="45720" anchor="ctr">
+                    <a:lnL w="9525" cap="flat" cmpd="sng" algn="ctr">
+                      <a:solidFill>
+                        <a:srgbClr val="38383E"/>
+                      </a:solidFill>
+                      <a:prstDash val="solid"/>
+                      <a:round/>
+                      <a:headEnd type="none" w="med" len="med"/>
+                      <a:tailEnd type="none" w="med" len="med"/>
+                    </a:lnL>
+                    <a:lnR w="9525" cap="flat" cmpd="sng" algn="ctr">
+                      <a:solidFill>
+                        <a:srgbClr val="38383E"/>
+                      </a:solidFill>
+                      <a:prstDash val="solid"/>
+                      <a:round/>
+                      <a:headEnd type="none" w="med" len="med"/>
+                      <a:tailEnd type="none" w="med" len="med"/>
+                    </a:lnR>
+                    <a:lnT w="9525" cap="flat" cmpd="sng" algn="ctr">
+                      <a:solidFill>
+                        <a:srgbClr val="38383E"/>
+                      </a:solidFill>
+                      <a:prstDash val="solid"/>
+                      <a:round/>
+                      <a:headEnd type="none" w="med" len="med"/>
+                      <a:tailEnd type="none" w="med" len="med"/>
+                    </a:lnT>
+                    <a:lnB w="9525" cap="flat" cmpd="sng" algn="ctr">
+                      <a:solidFill>
+                        <a:srgbClr val="38383E"/>
+                      </a:solidFill>
+                      <a:prstDash val="solid"/>
+                      <a:round/>
+                      <a:headEnd type="none" w="med" len="med"/>
+                      <a:tailEnd type="none" w="med" len="med"/>
+                    </a:lnB>
+                    <a:solidFill>
+                      <a:srgbClr val="1F1F23"/>
+                    </a:solidFill>
+                  </a:tcPr>
+                </a:tc>
+                <a:tc>
+                  <a:txBody>
+                    <a:bodyPr/>
+                    <a:lstStyle/>
+                    <a:p>
+                      <a:pPr algn="ctr" indent="0" marL="0">
+                        <a:buNone/>
+                      </a:pPr>
+                      <a:r>
+                        <a:rPr lang="en-US" sz="1150" dirty="0">
+                          <a:solidFill>
+                            <a:srgbClr val="FFFFFF"/>
+                          </a:solidFill>
+                          <a:latin typeface="Consolas" pitchFamily="34" charset="0"/>
+                          <a:ea typeface="Consolas" pitchFamily="34" charset="-122"/>
+                          <a:cs typeface="Consolas" pitchFamily="34" charset="-120"/>
+                        </a:rPr>
+                        <a:t>6.78</a:t>
+                      </a:r>
+                      <a:endParaRPr lang="en-US" sz="1150" dirty="0">
+                        <a:latin typeface="Consolas" charset="0"/>
+                        <a:ea typeface="Consolas" charset="0"/>
+                        <a:cs typeface="Consolas" charset="0"/>
+                      </a:endParaRPr>
+                    </a:p>
+                  </a:txBody>
+                  <a:tcPr marL="91440" marR="91440" marT="45720" marB="45720" anchor="ctr">
+                    <a:lnL w="9525" cap="flat" cmpd="sng" algn="ctr">
+                      <a:solidFill>
+                        <a:srgbClr val="38383E"/>
+                      </a:solidFill>
+                      <a:prstDash val="solid"/>
+                      <a:round/>
+                      <a:headEnd type="none" w="med" len="med"/>
+                      <a:tailEnd type="none" w="med" len="med"/>
+                    </a:lnL>
+                    <a:lnR w="9525" cap="flat" cmpd="sng" algn="ctr">
+                      <a:solidFill>
+                        <a:srgbClr val="38383E"/>
+                      </a:solidFill>
+                      <a:prstDash val="solid"/>
+                      <a:round/>
+                      <a:headEnd type="none" w="med" len="med"/>
+                      <a:tailEnd type="none" w="med" len="med"/>
+                    </a:lnR>
+                    <a:lnT w="9525" cap="flat" cmpd="sng" algn="ctr">
+                      <a:solidFill>
+                        <a:srgbClr val="38383E"/>
+                      </a:solidFill>
+                      <a:prstDash val="solid"/>
+                      <a:round/>
+                      <a:headEnd type="none" w="med" len="med"/>
+                      <a:tailEnd type="none" w="med" len="med"/>
+                    </a:lnT>
+                    <a:lnB w="9525" cap="flat" cmpd="sng" algn="ctr">
+                      <a:solidFill>
+                        <a:srgbClr val="38383E"/>
+                      </a:solidFill>
+                      <a:prstDash val="solid"/>
+                      <a:round/>
+                      <a:headEnd type="none" w="med" len="med"/>
+                      <a:tailEnd type="none" w="med" len="med"/>
+                    </a:lnB>
+                    <a:solidFill>
+                      <a:srgbClr val="1F1F23"/>
+                    </a:solidFill>
+                  </a:tcPr>
+                </a:tc>
+                <a:tc>
+                  <a:txBody>
+                    <a:bodyPr/>
+                    <a:lstStyle/>
+                    <a:p>
+                      <a:pPr algn="ctr" indent="0" marL="0">
+                        <a:buNone/>
+                      </a:pPr>
+                      <a:r>
+                        <a:rPr lang="en-US" sz="1150" dirty="0">
+                          <a:solidFill>
+                            <a:srgbClr val="FFFFFF"/>
+                          </a:solidFill>
+                          <a:latin typeface="Consolas" pitchFamily="34" charset="0"/>
+                          <a:ea typeface="Consolas" pitchFamily="34" charset="-122"/>
+                          <a:cs typeface="Consolas" pitchFamily="34" charset="-120"/>
+                        </a:rPr>
+                        <a:t>8.18</a:t>
+                      </a:r>
+                      <a:endParaRPr lang="en-US" sz="1150" dirty="0">
+                        <a:latin typeface="Consolas" charset="0"/>
+                        <a:ea typeface="Consolas" charset="0"/>
+                        <a:cs typeface="Consolas" charset="0"/>
+                      </a:endParaRPr>
+                    </a:p>
+                  </a:txBody>
+                  <a:tcPr marL="91440" marR="91440" marT="45720" marB="45720" anchor="ctr">
+                    <a:lnL w="9525" cap="flat" cmpd="sng" algn="ctr">
+                      <a:solidFill>
+                        <a:srgbClr val="38383E"/>
+                      </a:solidFill>
+                      <a:prstDash val="solid"/>
+                      <a:round/>
+                      <a:headEnd type="none" w="med" len="med"/>
+                      <a:tailEnd type="none" w="med" len="med"/>
+                    </a:lnL>
+                    <a:lnR w="9525" cap="flat" cmpd="sng" algn="ctr">
+                      <a:solidFill>
+                        <a:srgbClr val="38383E"/>
+                      </a:solidFill>
+                      <a:prstDash val="solid"/>
+                      <a:round/>
+                      <a:headEnd type="none" w="med" len="med"/>
+                      <a:tailEnd type="none" w="med" len="med"/>
+                    </a:lnR>
+                    <a:lnT w="9525" cap="flat" cmpd="sng" algn="ctr">
+                      <a:solidFill>
+                        <a:srgbClr val="38383E"/>
+                      </a:solidFill>
+                      <a:prstDash val="solid"/>
+                      <a:round/>
+                      <a:headEnd type="none" w="med" len="med"/>
+                      <a:tailEnd type="none" w="med" len="med"/>
+                    </a:lnT>
+                    <a:lnB w="9525" cap="flat" cmpd="sng" algn="ctr">
+                      <a:solidFill>
+                        <a:srgbClr val="38383E"/>
+                      </a:solidFill>
+                      <a:prstDash val="solid"/>
+                      <a:round/>
+                      <a:headEnd type="none" w="med" len="med"/>
+                      <a:tailEnd type="none" w="med" len="med"/>
+                    </a:lnB>
+                    <a:solidFill>
+                      <a:srgbClr val="1F1F23"/>
+                    </a:solidFill>
+                  </a:tcPr>
+                </a:tc>
+                <a:tc>
+                  <a:txBody>
+                    <a:bodyPr/>
+                    <a:lstStyle/>
+                    <a:p>
+                      <a:pPr algn="ctr" indent="0" marL="0">
+                        <a:buNone/>
+                      </a:pPr>
+                      <a:r>
+                        <a:rPr lang="en-US" sz="1150" dirty="0">
+                          <a:solidFill>
+                            <a:srgbClr val="FFFFFF"/>
+                          </a:solidFill>
+                          <a:latin typeface="Consolas" pitchFamily="34" charset="0"/>
+                          <a:ea typeface="Consolas" pitchFamily="34" charset="-122"/>
+                          <a:cs typeface="Consolas" pitchFamily="34" charset="-120"/>
+                        </a:rPr>
+                        <a:t>8.02</a:t>
+                      </a:r>
+                      <a:endParaRPr lang="en-US" sz="1150" dirty="0">
+                        <a:latin typeface="Consolas" charset="0"/>
+                        <a:ea typeface="Consolas" charset="0"/>
+                        <a:cs typeface="Consolas" charset="0"/>
+                      </a:endParaRPr>
+                    </a:p>
+                  </a:txBody>
+                  <a:tcPr marL="91440" marR="91440" marT="45720" marB="45720" anchor="ctr">
+                    <a:lnL w="9525" cap="flat" cmpd="sng" algn="ctr">
+                      <a:solidFill>
+                        <a:srgbClr val="38383E"/>
+                      </a:solidFill>
+                      <a:prstDash val="solid"/>
+                      <a:round/>
+                      <a:headEnd type="none" w="med" len="med"/>
+                      <a:tailEnd type="none" w="med" len="med"/>
+                    </a:lnL>
+                    <a:lnR w="9525" cap="flat" cmpd="sng" algn="ctr">
+                      <a:solidFill>
+                        <a:srgbClr val="38383E"/>
+                      </a:solidFill>
+                      <a:prstDash val="solid"/>
+                      <a:round/>
+                      <a:headEnd type="none" w="med" len="med"/>
+                      <a:tailEnd type="none" w="med" len="med"/>
+                    </a:lnR>
+                    <a:lnT w="9525" cap="flat" cmpd="sng" algn="ctr">
+                      <a:solidFill>
+                        <a:srgbClr val="38383E"/>
+                      </a:solidFill>
+                      <a:prstDash val="solid"/>
+                      <a:round/>
+                      <a:headEnd type="none" w="med" len="med"/>
+                      <a:tailEnd type="none" w="med" len="med"/>
+                    </a:lnT>
+                    <a:lnB w="9525" cap="flat" cmpd="sng" algn="ctr">
+                      <a:solidFill>
+                        <a:srgbClr val="38383E"/>
+                      </a:solidFill>
+                      <a:prstDash val="solid"/>
+                      <a:round/>
+                      <a:headEnd type="none" w="med" len="med"/>
+                      <a:tailEnd type="none" w="med" len="med"/>
+                    </a:lnB>
+                    <a:solidFill>
+                      <a:srgbClr val="1F1F23"/>
+                    </a:solidFill>
+                  </a:tcPr>
+                </a:tc>
+                <a:tc>
+                  <a:txBody>
+                    <a:bodyPr/>
+                    <a:lstStyle/>
+                    <a:p>
+                      <a:pPr algn="ctr" indent="0" marL="0">
+                        <a:buNone/>
+                      </a:pPr>
+                      <a:r>
+                        <a:rPr lang="en-US" sz="1150" b="1" dirty="0">
+                          <a:solidFill>
+                            <a:srgbClr val="FFFFFF"/>
+                          </a:solidFill>
+                          <a:latin typeface="Consolas" pitchFamily="34" charset="0"/>
+                          <a:ea typeface="Consolas" pitchFamily="34" charset="-122"/>
+                          <a:cs typeface="Consolas" pitchFamily="34" charset="-120"/>
+                        </a:rPr>
+                        <a:t>7.72</a:t>
+                      </a:r>
+                      <a:endParaRPr lang="en-US" sz="1150" dirty="0">
+                        <a:latin typeface="Consolas" charset="0"/>
+                        <a:ea typeface="Consolas" charset="0"/>
+                        <a:cs typeface="Consolas" charset="0"/>
+                      </a:endParaRPr>
+                    </a:p>
+                  </a:txBody>
+                  <a:tcPr marL="91440" marR="91440" marT="45720" marB="45720" anchor="ctr">
+                    <a:lnL w="9525" cap="flat" cmpd="sng" algn="ctr">
+                      <a:solidFill>
+                        <a:srgbClr val="38383E"/>
+                      </a:solidFill>
+                      <a:prstDash val="solid"/>
+                      <a:round/>
+                      <a:headEnd type="none" w="med" len="med"/>
+                      <a:tailEnd type="none" w="med" len="med"/>
+                    </a:lnL>
+                    <a:lnR w="9525" cap="flat" cmpd="sng" algn="ctr">
+                      <a:solidFill>
+                        <a:srgbClr val="38383E"/>
+                      </a:solidFill>
+                      <a:prstDash val="solid"/>
+                      <a:round/>
+                      <a:headEnd type="none" w="med" len="med"/>
+                      <a:tailEnd type="none" w="med" len="med"/>
+                    </a:lnR>
+                    <a:lnT w="9525" cap="flat" cmpd="sng" algn="ctr">
+                      <a:solidFill>
+                        <a:srgbClr val="38383E"/>
+                      </a:solidFill>
+                      <a:prstDash val="solid"/>
+                      <a:round/>
+                      <a:headEnd type="none" w="med" len="med"/>
+                      <a:tailEnd type="none" w="med" len="med"/>
+                    </a:lnT>
+                    <a:lnB w="9525" cap="flat" cmpd="sng" algn="ctr">
+                      <a:solidFill>
+                        <a:srgbClr val="38383E"/>
+                      </a:solidFill>
+                      <a:prstDash val="solid"/>
+                      <a:round/>
+                      <a:headEnd type="none" w="med" len="med"/>
+                      <a:tailEnd type="none" w="med" len="med"/>
+                    </a:lnB>
+                    <a:solidFill>
+                      <a:srgbClr val="1F1F23"/>
+                    </a:solidFill>
+                  </a:tcPr>
+                </a:tc>
+              </a:tr>
+              <a:tr h="310896">
+                <a:tc>
+                  <a:txBody>
+                    <a:bodyPr/>
+                    <a:lstStyle/>
+                    <a:p>
+                      <a:pPr algn="ctr" indent="0" marL="0">
+                        <a:buNone/>
+                      </a:pPr>
+                      <a:r>
+                        <a:rPr lang="en-US" sz="1150" b="1" dirty="0">
+                          <a:solidFill>
+                            <a:srgbClr val="FFFFFF"/>
+                          </a:solidFill>
+                          <a:latin typeface="Consolas" pitchFamily="34" charset="0"/>
+                          <a:ea typeface="Consolas" pitchFamily="34" charset="-122"/>
+                          <a:cs typeface="Consolas" pitchFamily="34" charset="-120"/>
+                        </a:rPr>
+                        <a:t>Gemma tuned v1</a:t>
+                      </a:r>
+                      <a:endParaRPr lang="en-US" sz="1150" dirty="0">
+                        <a:latin typeface="Consolas" charset="0"/>
+                        <a:ea typeface="Consolas" charset="0"/>
+                        <a:cs typeface="Consolas" charset="0"/>
+                      </a:endParaRPr>
+                    </a:p>
+                  </a:txBody>
+                  <a:tcPr marL="91440" marR="91440" marT="45720" marB="45720" anchor="ctr">
+                    <a:lnL w="9525" cap="flat" cmpd="sng" algn="ctr">
+                      <a:solidFill>
+                        <a:srgbClr val="38383E"/>
+                      </a:solidFill>
+                      <a:prstDash val="solid"/>
+                      <a:round/>
+                      <a:headEnd type="none" w="med" len="med"/>
+                      <a:tailEnd type="none" w="med" len="med"/>
+                    </a:lnL>
+                    <a:lnR w="9525" cap="flat" cmpd="sng" algn="ctr">
+                      <a:solidFill>
+                        <a:srgbClr val="38383E"/>
+                      </a:solidFill>
+                      <a:prstDash val="solid"/>
+                      <a:round/>
+                      <a:headEnd type="none" w="med" len="med"/>
+                      <a:tailEnd type="none" w="med" len="med"/>
+                    </a:lnR>
+                    <a:lnT w="9525" cap="flat" cmpd="sng" algn="ctr">
+                      <a:solidFill>
+                        <a:srgbClr val="38383E"/>
+                      </a:solidFill>
+                      <a:prstDash val="solid"/>
+                      <a:round/>
+                      <a:headEnd type="none" w="med" len="med"/>
+                      <a:tailEnd type="none" w="med" len="med"/>
+                    </a:lnT>
+                    <a:lnB w="9525" cap="flat" cmpd="sng" algn="ctr">
+                      <a:solidFill>
+                        <a:srgbClr val="38383E"/>
+                      </a:solidFill>
+                      <a:prstDash val="solid"/>
+                      <a:round/>
+                      <a:headEnd type="none" w="med" len="med"/>
+                      <a:tailEnd type="none" w="med" len="med"/>
+                    </a:lnB>
+                    <a:solidFill>
+                      <a:srgbClr val="1F1F23"/>
+                    </a:solidFill>
+                  </a:tcPr>
+                </a:tc>
+                <a:tc>
+                  <a:txBody>
+                    <a:bodyPr/>
+                    <a:lstStyle/>
+                    <a:p>
+                      <a:pPr algn="ctr" indent="0" marL="0">
+                        <a:buNone/>
+                      </a:pPr>
+                      <a:r>
+                        <a:rPr lang="en-US" sz="1150" dirty="0">
+                          <a:solidFill>
+                            <a:srgbClr val="FFFFFF"/>
+                          </a:solidFill>
+                          <a:latin typeface="Consolas" pitchFamily="34" charset="0"/>
+                          <a:ea typeface="Consolas" pitchFamily="34" charset="-122"/>
+                          <a:cs typeface="Consolas" pitchFamily="34" charset="-120"/>
+                        </a:rPr>
+                        <a:t>7.90</a:t>
+                      </a:r>
+                      <a:endParaRPr lang="en-US" sz="1150" dirty="0">
+                        <a:latin typeface="Consolas" charset="0"/>
+                        <a:ea typeface="Consolas" charset="0"/>
+                        <a:cs typeface="Consolas" charset="0"/>
+                      </a:endParaRPr>
+                    </a:p>
+                  </a:txBody>
+                  <a:tcPr marL="91440" marR="91440" marT="45720" marB="45720" anchor="ctr">
+                    <a:lnL w="9525" cap="flat" cmpd="sng" algn="ctr">
+                      <a:solidFill>
+                        <a:srgbClr val="38383E"/>
+                      </a:solidFill>
+                      <a:prstDash val="solid"/>
+                      <a:round/>
+                      <a:headEnd type="none" w="med" len="med"/>
+                      <a:tailEnd type="none" w="med" len="med"/>
+                    </a:lnL>
+                    <a:lnR w="9525" cap="flat" cmpd="sng" algn="ctr">
+                      <a:solidFill>
+                        <a:srgbClr val="38383E"/>
+                      </a:solidFill>
+                      <a:prstDash val="solid"/>
+                      <a:round/>
+                      <a:headEnd type="none" w="med" len="med"/>
+                      <a:tailEnd type="none" w="med" len="med"/>
+                    </a:lnR>
+                    <a:lnT w="9525" cap="flat" cmpd="sng" algn="ctr">
+                      <a:solidFill>
+                        <a:srgbClr val="38383E"/>
+                      </a:solidFill>
+                      <a:prstDash val="solid"/>
+                      <a:round/>
+                      <a:headEnd type="none" w="med" len="med"/>
+                      <a:tailEnd type="none" w="med" len="med"/>
+                    </a:lnT>
+                    <a:lnB w="9525" cap="flat" cmpd="sng" algn="ctr">
+                      <a:solidFill>
+                        <a:srgbClr val="38383E"/>
+                      </a:solidFill>
+                      <a:prstDash val="solid"/>
+                      <a:round/>
+                      <a:headEnd type="none" w="med" len="med"/>
+                      <a:tailEnd type="none" w="med" len="med"/>
+                    </a:lnB>
+                    <a:solidFill>
+                      <a:srgbClr val="1F1F23"/>
+                    </a:solidFill>
+                  </a:tcPr>
+                </a:tc>
+                <a:tc>
+                  <a:txBody>
+                    <a:bodyPr/>
+                    <a:lstStyle/>
+                    <a:p>
+                      <a:pPr algn="ctr" indent="0" marL="0">
+                        <a:buNone/>
+                      </a:pPr>
+                      <a:r>
+                        <a:rPr lang="en-US" sz="1150" dirty="0">
+                          <a:solidFill>
+                            <a:srgbClr val="FFFFFF"/>
+                          </a:solidFill>
+                          <a:latin typeface="Consolas" pitchFamily="34" charset="0"/>
+                          <a:ea typeface="Consolas" pitchFamily="34" charset="-122"/>
+                          <a:cs typeface="Consolas" pitchFamily="34" charset="-120"/>
+                        </a:rPr>
+                        <a:t>7.32</a:t>
+                      </a:r>
+                      <a:endParaRPr lang="en-US" sz="1150" dirty="0">
+                        <a:latin typeface="Consolas" charset="0"/>
+                        <a:ea typeface="Consolas" charset="0"/>
+                        <a:cs typeface="Consolas" charset="0"/>
+                      </a:endParaRPr>
+                    </a:p>
+                  </a:txBody>
+                  <a:tcPr marL="91440" marR="91440" marT="45720" marB="45720" anchor="ctr">
+                    <a:lnL w="9525" cap="flat" cmpd="sng" algn="ctr">
+                      <a:solidFill>
+                        <a:srgbClr val="38383E"/>
+                      </a:solidFill>
+                      <a:prstDash val="solid"/>
+                      <a:round/>
+                      <a:headEnd type="none" w="med" len="med"/>
+                      <a:tailEnd type="none" w="med" len="med"/>
+                    </a:lnL>
+                    <a:lnR w="9525" cap="flat" cmpd="sng" algn="ctr">
+                      <a:solidFill>
+                        <a:srgbClr val="38383E"/>
+                      </a:solidFill>
+                      <a:prstDash val="solid"/>
+                      <a:round/>
+                      <a:headEnd type="none" w="med" len="med"/>
+                      <a:tailEnd type="none" w="med" len="med"/>
+                    </a:lnR>
+                    <a:lnT w="9525" cap="flat" cmpd="sng" algn="ctr">
+                      <a:solidFill>
+                        <a:srgbClr val="38383E"/>
+                      </a:solidFill>
+                      <a:prstDash val="solid"/>
+                      <a:round/>
+                      <a:headEnd type="none" w="med" len="med"/>
+                      <a:tailEnd type="none" w="med" len="med"/>
+                    </a:lnT>
+                    <a:lnB w="9525" cap="flat" cmpd="sng" algn="ctr">
+                      <a:solidFill>
+                        <a:srgbClr val="38383E"/>
+                      </a:solidFill>
+                      <a:prstDash val="solid"/>
+                      <a:round/>
+                      <a:headEnd type="none" w="med" len="med"/>
+                      <a:tailEnd type="none" w="med" len="med"/>
+                    </a:lnB>
+                    <a:solidFill>
+                      <a:srgbClr val="1F1F23"/>
+                    </a:solidFill>
+                  </a:tcPr>
+                </a:tc>
+                <a:tc>
+                  <a:txBody>
+                    <a:bodyPr/>
+                    <a:lstStyle/>
+                    <a:p>
+                      <a:pPr algn="ctr" indent="0" marL="0">
+                        <a:buNone/>
+                      </a:pPr>
+                      <a:r>
+                        <a:rPr lang="en-US" sz="1150" dirty="0">
+                          <a:solidFill>
+                            <a:srgbClr val="FFFFFF"/>
+                          </a:solidFill>
+                          <a:latin typeface="Consolas" pitchFamily="34" charset="0"/>
+                          <a:ea typeface="Consolas" pitchFamily="34" charset="-122"/>
+                          <a:cs typeface="Consolas" pitchFamily="34" charset="-120"/>
+                        </a:rPr>
+                        <a:t>7.82</a:t>
+                      </a:r>
+                      <a:endParaRPr lang="en-US" sz="1150" dirty="0">
+                        <a:latin typeface="Consolas" charset="0"/>
+                        <a:ea typeface="Consolas" charset="0"/>
+                        <a:cs typeface="Consolas" charset="0"/>
+                      </a:endParaRPr>
+                    </a:p>
+                  </a:txBody>
+                  <a:tcPr marL="91440" marR="91440" marT="45720" marB="45720" anchor="ctr">
+                    <a:lnL w="9525" cap="flat" cmpd="sng" algn="ctr">
+                      <a:solidFill>
+                        <a:srgbClr val="38383E"/>
+                      </a:solidFill>
+                      <a:prstDash val="solid"/>
+                      <a:round/>
+                      <a:headEnd type="none" w="med" len="med"/>
+                      <a:tailEnd type="none" w="med" len="med"/>
+                    </a:lnL>
+                    <a:lnR w="9525" cap="flat" cmpd="sng" algn="ctr">
+                      <a:solidFill>
+                        <a:srgbClr val="38383E"/>
+                      </a:solidFill>
+                      <a:prstDash val="solid"/>
+                      <a:round/>
+                      <a:headEnd type="none" w="med" len="med"/>
+                      <a:tailEnd type="none" w="med" len="med"/>
+                    </a:lnR>
+                    <a:lnT w="9525" cap="flat" cmpd="sng" algn="ctr">
+                      <a:solidFill>
+                        <a:srgbClr val="38383E"/>
+                      </a:solidFill>
+                      <a:prstDash val="solid"/>
+                      <a:round/>
+                      <a:headEnd type="none" w="med" len="med"/>
+                      <a:tailEnd type="none" w="med" len="med"/>
+                    </a:lnT>
+                    <a:lnB w="9525" cap="flat" cmpd="sng" algn="ctr">
+                      <a:solidFill>
+                        <a:srgbClr val="38383E"/>
+                      </a:solidFill>
+                      <a:prstDash val="solid"/>
+                      <a:round/>
+                      <a:headEnd type="none" w="med" len="med"/>
+                      <a:tailEnd type="none" w="med" len="med"/>
+                    </a:lnB>
+                    <a:solidFill>
+                      <a:srgbClr val="1F1F23"/>
+                    </a:solidFill>
+                  </a:tcPr>
+                </a:tc>
+                <a:tc>
+                  <a:txBody>
+                    <a:bodyPr/>
+                    <a:lstStyle/>
+                    <a:p>
+                      <a:pPr algn="ctr" indent="0" marL="0">
+                        <a:buNone/>
+                      </a:pPr>
+                      <a:r>
+                        <a:rPr lang="en-US" sz="1150" dirty="0">
+                          <a:solidFill>
+                            <a:srgbClr val="FFFFFF"/>
+                          </a:solidFill>
+                          <a:latin typeface="Consolas" pitchFamily="34" charset="0"/>
+                          <a:ea typeface="Consolas" pitchFamily="34" charset="-122"/>
+                          <a:cs typeface="Consolas" pitchFamily="34" charset="-120"/>
+                        </a:rPr>
+                        <a:t>7.97</a:t>
+                      </a:r>
+                      <a:endParaRPr lang="en-US" sz="1150" dirty="0">
+                        <a:latin typeface="Consolas" charset="0"/>
+                        <a:ea typeface="Consolas" charset="0"/>
+                        <a:cs typeface="Consolas" charset="0"/>
+                      </a:endParaRPr>
+                    </a:p>
+                  </a:txBody>
+                  <a:tcPr marL="91440" marR="91440" marT="45720" marB="45720" anchor="ctr">
+                    <a:lnL w="9525" cap="flat" cmpd="sng" algn="ctr">
+                      <a:solidFill>
+                        <a:srgbClr val="38383E"/>
+                      </a:solidFill>
+                      <a:prstDash val="solid"/>
+                      <a:round/>
+                      <a:headEnd type="none" w="med" len="med"/>
+                      <a:tailEnd type="none" w="med" len="med"/>
+                    </a:lnL>
+                    <a:lnR w="9525" cap="flat" cmpd="sng" algn="ctr">
+                      <a:solidFill>
+                        <a:srgbClr val="38383E"/>
+                      </a:solidFill>
+                      <a:prstDash val="solid"/>
+                      <a:round/>
+                      <a:headEnd type="none" w="med" len="med"/>
+                      <a:tailEnd type="none" w="med" len="med"/>
+                    </a:lnR>
+                    <a:lnT w="9525" cap="flat" cmpd="sng" algn="ctr">
+                      <a:solidFill>
+                        <a:srgbClr val="38383E"/>
+                      </a:solidFill>
+                      <a:prstDash val="solid"/>
+                      <a:round/>
+                      <a:headEnd type="none" w="med" len="med"/>
+                      <a:tailEnd type="none" w="med" len="med"/>
+                    </a:lnT>
+                    <a:lnB w="9525" cap="flat" cmpd="sng" algn="ctr">
+                      <a:solidFill>
+                        <a:srgbClr val="38383E"/>
+                      </a:solidFill>
+                      <a:prstDash val="solid"/>
+                      <a:round/>
+                      <a:headEnd type="none" w="med" len="med"/>
+                      <a:tailEnd type="none" w="med" len="med"/>
+                    </a:lnB>
+                    <a:solidFill>
+                      <a:srgbClr val="1F1F23"/>
+                    </a:solidFill>
+                  </a:tcPr>
+                </a:tc>
+                <a:tc>
+                  <a:txBody>
+                    <a:bodyPr/>
+                    <a:lstStyle/>
+                    <a:p>
+                      <a:pPr algn="ctr" indent="0" marL="0">
+                        <a:buNone/>
+                      </a:pPr>
+                      <a:r>
+                        <a:rPr lang="en-US" sz="1150" b="1" dirty="0">
+                          <a:solidFill>
+                            <a:srgbClr val="FFFFFF"/>
+                          </a:solidFill>
+                          <a:latin typeface="Consolas" pitchFamily="34" charset="0"/>
+                          <a:ea typeface="Consolas" pitchFamily="34" charset="-122"/>
+                          <a:cs typeface="Consolas" pitchFamily="34" charset="-120"/>
+                        </a:rPr>
+                        <a:t>7.75</a:t>
+                      </a:r>
+                      <a:endParaRPr lang="en-US" sz="1150" dirty="0">
+                        <a:latin typeface="Consolas" charset="0"/>
+                        <a:ea typeface="Consolas" charset="0"/>
+                        <a:cs typeface="Consolas" charset="0"/>
+                      </a:endParaRPr>
+                    </a:p>
+                  </a:txBody>
+                  <a:tcPr marL="91440" marR="91440" marT="45720" marB="45720" anchor="ctr">
+                    <a:lnL w="9525" cap="flat" cmpd="sng" algn="ctr">
+                      <a:solidFill>
+                        <a:srgbClr val="38383E"/>
+                      </a:solidFill>
+                      <a:prstDash val="solid"/>
+                      <a:round/>
+                      <a:headEnd type="none" w="med" len="med"/>
+                      <a:tailEnd type="none" w="med" len="med"/>
+                    </a:lnL>
+                    <a:lnR w="9525" cap="flat" cmpd="sng" algn="ctr">
+                      <a:solidFill>
+                        <a:srgbClr val="38383E"/>
+                      </a:solidFill>
+                      <a:prstDash val="solid"/>
+                      <a:round/>
+                      <a:headEnd type="none" w="med" len="med"/>
+                      <a:tailEnd type="none" w="med" len="med"/>
+                    </a:lnR>
+                    <a:lnT w="9525" cap="flat" cmpd="sng" algn="ctr">
+                      <a:solidFill>
+                        <a:srgbClr val="38383E"/>
+                      </a:solidFill>
+                      <a:prstDash val="solid"/>
+                      <a:round/>
+                      <a:headEnd type="none" w="med" len="med"/>
+                      <a:tailEnd type="none" w="med" len="med"/>
+                    </a:lnT>
+                    <a:lnB w="9525" cap="flat" cmpd="sng" algn="ctr">
+                      <a:solidFill>
+                        <a:srgbClr val="38383E"/>
+                      </a:solidFill>
+                      <a:prstDash val="solid"/>
+                      <a:round/>
+                      <a:headEnd type="none" w="med" len="med"/>
+                      <a:tailEnd type="none" w="med" len="med"/>
+                    </a:lnB>
+                    <a:solidFill>
+                      <a:srgbClr val="1F1F23"/>
+                    </a:solidFill>
+                  </a:tcPr>
+                </a:tc>
+              </a:tr>
+              <a:tr h="310896">
+                <a:tc>
+                  <a:txBody>
+                    <a:bodyPr/>
+                    <a:lstStyle/>
+                    <a:p>
+                      <a:pPr algn="ctr" indent="0" marL="0">
+                        <a:buNone/>
+                      </a:pPr>
+                      <a:r>
+                        <a:rPr lang="en-US" sz="1150" b="1" dirty="0">
+                          <a:solidFill>
+                            <a:srgbClr val="ED1C24"/>
+                          </a:solidFill>
+                          <a:latin typeface="Consolas" pitchFamily="34" charset="0"/>
+                          <a:ea typeface="Consolas" pitchFamily="34" charset="-122"/>
+                          <a:cs typeface="Consolas" pitchFamily="34" charset="-120"/>
+                        </a:rPr>
+                        <a:t>Gemma tuned v2</a:t>
+                      </a:r>
+                      <a:endParaRPr lang="en-US" sz="1150" dirty="0">
+                        <a:latin typeface="Consolas" charset="0"/>
+                        <a:ea typeface="Consolas" charset="0"/>
+                        <a:cs typeface="Consolas" charset="0"/>
+                      </a:endParaRPr>
+                    </a:p>
+                  </a:txBody>
+                  <a:tcPr marL="91440" marR="91440" marT="45720" marB="45720" anchor="ctr">
+                    <a:lnL w="9525" cap="flat" cmpd="sng" algn="ctr">
+                      <a:solidFill>
+                        <a:srgbClr val="38383E"/>
+                      </a:solidFill>
+                      <a:prstDash val="solid"/>
+                      <a:round/>
+                      <a:headEnd type="none" w="med" len="med"/>
+                      <a:tailEnd type="none" w="med" len="med"/>
+                    </a:lnL>
+                    <a:lnR w="9525" cap="flat" cmpd="sng" algn="ctr">
+                      <a:solidFill>
+                        <a:srgbClr val="38383E"/>
+                      </a:solidFill>
+                      <a:prstDash val="solid"/>
+                      <a:round/>
+                      <a:headEnd type="none" w="med" len="med"/>
+                      <a:tailEnd type="none" w="med" len="med"/>
+                    </a:lnR>
+                    <a:lnT w="9525" cap="flat" cmpd="sng" algn="ctr">
+                      <a:solidFill>
+                        <a:srgbClr val="38383E"/>
+                      </a:solidFill>
+                      <a:prstDash val="solid"/>
+                      <a:round/>
+                      <a:headEnd type="none" w="med" len="med"/>
+                      <a:tailEnd type="none" w="med" len="med"/>
+                    </a:lnT>
+                    <a:lnB w="9525" cap="flat" cmpd="sng" algn="ctr">
+                      <a:solidFill>
+                        <a:srgbClr val="38383E"/>
+                      </a:solidFill>
+                      <a:prstDash val="solid"/>
+                      <a:round/>
+                      <a:headEnd type="none" w="med" len="med"/>
+                      <a:tailEnd type="none" w="med" len="med"/>
+                    </a:lnB>
+                    <a:solidFill>
+                      <a:srgbClr val="1F1F23"/>
+                    </a:solidFill>
+                  </a:tcPr>
+                </a:tc>
+                <a:tc>
+                  <a:txBody>
+                    <a:bodyPr/>
+                    <a:lstStyle/>
+                    <a:p>
+                      <a:pPr algn="ctr" indent="0" marL="0">
+                        <a:buNone/>
+                      </a:pPr>
+                      <a:r>
+                        <a:rPr lang="en-US" sz="1150" dirty="0">
+                          <a:solidFill>
+                            <a:srgbClr val="FFFFFF"/>
+                          </a:solidFill>
+                          <a:latin typeface="Consolas" pitchFamily="34" charset="0"/>
+                          <a:ea typeface="Consolas" pitchFamily="34" charset="-122"/>
+                          <a:cs typeface="Consolas" pitchFamily="34" charset="-120"/>
+                        </a:rPr>
+                        <a:t>8.40</a:t>
+                      </a:r>
+                      <a:endParaRPr lang="en-US" sz="1150" dirty="0">
+                        <a:latin typeface="Consolas" charset="0"/>
+                        <a:ea typeface="Consolas" charset="0"/>
+                        <a:cs typeface="Consolas" charset="0"/>
+                      </a:endParaRPr>
+                    </a:p>
+                  </a:txBody>
+                  <a:tcPr marL="91440" marR="91440" marT="45720" marB="45720" anchor="ctr">
+                    <a:lnL w="9525" cap="flat" cmpd="sng" algn="ctr">
+                      <a:solidFill>
+                        <a:srgbClr val="38383E"/>
+                      </a:solidFill>
+                      <a:prstDash val="solid"/>
+                      <a:round/>
+                      <a:headEnd type="none" w="med" len="med"/>
+                      <a:tailEnd type="none" w="med" len="med"/>
+                    </a:lnL>
+                    <a:lnR w="9525" cap="flat" cmpd="sng" algn="ctr">
+                      <a:solidFill>
+                        <a:srgbClr val="38383E"/>
+                      </a:solidFill>
+                      <a:prstDash val="solid"/>
+                      <a:round/>
+                      <a:headEnd type="none" w="med" len="med"/>
+                      <a:tailEnd type="none" w="med" len="med"/>
+                    </a:lnR>
+                    <a:lnT w="9525" cap="flat" cmpd="sng" algn="ctr">
+                      <a:solidFill>
+                        <a:srgbClr val="38383E"/>
+                      </a:solidFill>
+                      <a:prstDash val="solid"/>
+                      <a:round/>
+                      <a:headEnd type="none" w="med" len="med"/>
+                      <a:tailEnd type="none" w="med" len="med"/>
+                    </a:lnT>
+                    <a:lnB w="9525" cap="flat" cmpd="sng" algn="ctr">
+                      <a:solidFill>
+                        <a:srgbClr val="38383E"/>
+                      </a:solidFill>
+                      <a:prstDash val="solid"/>
+                      <a:round/>
+                      <a:headEnd type="none" w="med" len="med"/>
+                      <a:tailEnd type="none" w="med" len="med"/>
+                    </a:lnB>
+                    <a:solidFill>
+                      <a:srgbClr val="1F1F23"/>
+                    </a:solidFill>
+                  </a:tcPr>
+                </a:tc>
+                <a:tc>
+                  <a:txBody>
+                    <a:bodyPr/>
+                    <a:lstStyle/>
+                    <a:p>
+                      <a:pPr algn="ctr" indent="0" marL="0">
+                        <a:buNone/>
+                      </a:pPr>
+                      <a:r>
+                        <a:rPr lang="en-US" sz="1150" dirty="0">
+                          <a:solidFill>
+                            <a:srgbClr val="FFFFFF"/>
+                          </a:solidFill>
+                          <a:latin typeface="Consolas" pitchFamily="34" charset="0"/>
+                          <a:ea typeface="Consolas" pitchFamily="34" charset="-122"/>
+                          <a:cs typeface="Consolas" pitchFamily="34" charset="-120"/>
+                        </a:rPr>
+                        <a:t>7.13</a:t>
+                      </a:r>
+                      <a:endParaRPr lang="en-US" sz="1150" dirty="0">
+                        <a:latin typeface="Consolas" charset="0"/>
+                        <a:ea typeface="Consolas" charset="0"/>
+                        <a:cs typeface="Consolas" charset="0"/>
+                      </a:endParaRPr>
+                    </a:p>
+                  </a:txBody>
+                  <a:tcPr marL="91440" marR="91440" marT="45720" marB="45720" anchor="ctr">
+                    <a:lnL w="9525" cap="flat" cmpd="sng" algn="ctr">
+                      <a:solidFill>
+                        <a:srgbClr val="38383E"/>
+                      </a:solidFill>
+                      <a:prstDash val="solid"/>
+                      <a:round/>
+                      <a:headEnd type="none" w="med" len="med"/>
+                      <a:tailEnd type="none" w="med" len="med"/>
+                    </a:lnL>
+                    <a:lnR w="9525" cap="flat" cmpd="sng" algn="ctr">
+                      <a:solidFill>
+                        <a:srgbClr val="38383E"/>
+                      </a:solidFill>
+                      <a:prstDash val="solid"/>
+                      <a:round/>
+                      <a:headEnd type="none" w="med" len="med"/>
+                      <a:tailEnd type="none" w="med" len="med"/>
+                    </a:lnR>
+                    <a:lnT w="9525" cap="flat" cmpd="sng" algn="ctr">
+                      <a:solidFill>
+                        <a:srgbClr val="38383E"/>
+                      </a:solidFill>
+                      <a:prstDash val="solid"/>
+                      <a:round/>
+                      <a:headEnd type="none" w="med" len="med"/>
+                      <a:tailEnd type="none" w="med" len="med"/>
+                    </a:lnT>
+                    <a:lnB w="9525" cap="flat" cmpd="sng" algn="ctr">
+                      <a:solidFill>
+                        <a:srgbClr val="38383E"/>
+                      </a:solidFill>
+                      <a:prstDash val="solid"/>
+                      <a:round/>
+                      <a:headEnd type="none" w="med" len="med"/>
+                      <a:tailEnd type="none" w="med" len="med"/>
+                    </a:lnB>
+                    <a:solidFill>
+                      <a:srgbClr val="1F1F23"/>
+                    </a:solidFill>
+                  </a:tcPr>
+                </a:tc>
+                <a:tc>
+                  <a:txBody>
+                    <a:bodyPr/>
+                    <a:lstStyle/>
+                    <a:p>
+                      <a:pPr algn="ctr" indent="0" marL="0">
+                        <a:buNone/>
+                      </a:pPr>
+                      <a:r>
+                        <a:rPr lang="en-US" sz="1150" dirty="0">
+                          <a:solidFill>
+                            <a:srgbClr val="FFFFFF"/>
+                          </a:solidFill>
+                          <a:latin typeface="Consolas" pitchFamily="34" charset="0"/>
+                          <a:ea typeface="Consolas" pitchFamily="34" charset="-122"/>
+                          <a:cs typeface="Consolas" pitchFamily="34" charset="-120"/>
+                        </a:rPr>
+                        <a:t>7.93</a:t>
+                      </a:r>
+                      <a:endParaRPr lang="en-US" sz="1150" dirty="0">
+                        <a:latin typeface="Consolas" charset="0"/>
+                        <a:ea typeface="Consolas" charset="0"/>
+                        <a:cs typeface="Consolas" charset="0"/>
+                      </a:endParaRPr>
+                    </a:p>
+                  </a:txBody>
+                  <a:tcPr marL="91440" marR="91440" marT="45720" marB="45720" anchor="ctr">
+                    <a:lnL w="9525" cap="flat" cmpd="sng" algn="ctr">
+                      <a:solidFill>
+                        <a:srgbClr val="38383E"/>
+                      </a:solidFill>
+                      <a:prstDash val="solid"/>
+                      <a:round/>
+                      <a:headEnd type="none" w="med" len="med"/>
+                      <a:tailEnd type="none" w="med" len="med"/>
+                    </a:lnL>
+                    <a:lnR w="9525" cap="flat" cmpd="sng" algn="ctr">
+                      <a:solidFill>
+                        <a:srgbClr val="38383E"/>
+                      </a:solidFill>
+                      <a:prstDash val="solid"/>
+                      <a:round/>
+                      <a:headEnd type="none" w="med" len="med"/>
+                      <a:tailEnd type="none" w="med" len="med"/>
+                    </a:lnR>
+                    <a:lnT w="9525" cap="flat" cmpd="sng" algn="ctr">
+                      <a:solidFill>
+                        <a:srgbClr val="38383E"/>
+                      </a:solidFill>
+                      <a:prstDash val="solid"/>
+                      <a:round/>
+                      <a:headEnd type="none" w="med" len="med"/>
+                      <a:tailEnd type="none" w="med" len="med"/>
+                    </a:lnT>
+                    <a:lnB w="9525" cap="flat" cmpd="sng" algn="ctr">
+                      <a:solidFill>
+                        <a:srgbClr val="38383E"/>
+                      </a:solidFill>
+                      <a:prstDash val="solid"/>
+                      <a:round/>
+                      <a:headEnd type="none" w="med" len="med"/>
+                      <a:tailEnd type="none" w="med" len="med"/>
+                    </a:lnB>
+                    <a:solidFill>
+                      <a:srgbClr val="1F1F23"/>
+                    </a:solidFill>
+                  </a:tcPr>
+                </a:tc>
+                <a:tc>
+                  <a:txBody>
+                    <a:bodyPr/>
+                    <a:lstStyle/>
+                    <a:p>
+                      <a:pPr algn="ctr" indent="0" marL="0">
+                        <a:buNone/>
+                      </a:pPr>
+                      <a:r>
+                        <a:rPr lang="en-US" sz="1150" dirty="0">
+                          <a:solidFill>
+                            <a:srgbClr val="FFFFFF"/>
+                          </a:solidFill>
+                          <a:latin typeface="Consolas" pitchFamily="34" charset="0"/>
+                          <a:ea typeface="Consolas" pitchFamily="34" charset="-122"/>
+                          <a:cs typeface="Consolas" pitchFamily="34" charset="-120"/>
+                        </a:rPr>
+                        <a:t>7.83</a:t>
+                      </a:r>
+                      <a:endParaRPr lang="en-US" sz="1150" dirty="0">
+                        <a:latin typeface="Consolas" charset="0"/>
+                        <a:ea typeface="Consolas" charset="0"/>
+                        <a:cs typeface="Consolas" charset="0"/>
+                      </a:endParaRPr>
+                    </a:p>
+                  </a:txBody>
+                  <a:tcPr marL="91440" marR="91440" marT="45720" marB="45720" anchor="ctr">
+                    <a:lnL w="9525" cap="flat" cmpd="sng" algn="ctr">
+                      <a:solidFill>
+                        <a:srgbClr val="38383E"/>
+                      </a:solidFill>
+                      <a:prstDash val="solid"/>
+                      <a:round/>
+                      <a:headEnd type="none" w="med" len="med"/>
+                      <a:tailEnd type="none" w="med" len="med"/>
+                    </a:lnL>
+                    <a:lnR w="9525" cap="flat" cmpd="sng" algn="ctr">
+                      <a:solidFill>
+                        <a:srgbClr val="38383E"/>
+                      </a:solidFill>
+                      <a:prstDash val="solid"/>
+                      <a:round/>
+                      <a:headEnd type="none" w="med" len="med"/>
+                      <a:tailEnd type="none" w="med" len="med"/>
+                    </a:lnR>
+                    <a:lnT w="9525" cap="flat" cmpd="sng" algn="ctr">
+                      <a:solidFill>
+                        <a:srgbClr val="38383E"/>
+                      </a:solidFill>
+                      <a:prstDash val="solid"/>
+                      <a:round/>
+                      <a:headEnd type="none" w="med" len="med"/>
+                      <a:tailEnd type="none" w="med" len="med"/>
+                    </a:lnT>
+                    <a:lnB w="9525" cap="flat" cmpd="sng" algn="ctr">
+                      <a:solidFill>
+                        <a:srgbClr val="38383E"/>
+                      </a:solidFill>
+                      <a:prstDash val="solid"/>
+                      <a:round/>
+                      <a:headEnd type="none" w="med" len="med"/>
+                      <a:tailEnd type="none" w="med" len="med"/>
+                    </a:lnB>
+                    <a:solidFill>
+                      <a:srgbClr val="1F1F23"/>
+                    </a:solidFill>
+                  </a:tcPr>
+                </a:tc>
+                <a:tc>
+                  <a:txBody>
+                    <a:bodyPr/>
+                    <a:lstStyle/>
+                    <a:p>
+                      <a:pPr algn="ctr" indent="0" marL="0">
+                        <a:buNone/>
+                      </a:pPr>
+                      <a:r>
+                        <a:rPr lang="en-US" sz="1150" b="1" dirty="0">
+                          <a:solidFill>
+                            <a:srgbClr val="FFFFFF"/>
+                          </a:solidFill>
+                          <a:latin typeface="Consolas" pitchFamily="34" charset="0"/>
+                          <a:ea typeface="Consolas" pitchFamily="34" charset="-122"/>
+                          <a:cs typeface="Consolas" pitchFamily="34" charset="-120"/>
+                        </a:rPr>
+                        <a:t>7.83</a:t>
+                      </a:r>
+                      <a:endParaRPr lang="en-US" sz="1150" dirty="0">
+                        <a:latin typeface="Consolas" charset="0"/>
+                        <a:ea typeface="Consolas" charset="0"/>
+                        <a:cs typeface="Consolas" charset="0"/>
+                      </a:endParaRPr>
+                    </a:p>
+                  </a:txBody>
+                  <a:tcPr marL="91440" marR="91440" marT="45720" marB="45720" anchor="ctr">
+                    <a:lnL w="9525" cap="flat" cmpd="sng" algn="ctr">
+                      <a:solidFill>
+                        <a:srgbClr val="38383E"/>
+                      </a:solidFill>
+                      <a:prstDash val="solid"/>
+                      <a:round/>
+                      <a:headEnd type="none" w="med" len="med"/>
+                      <a:tailEnd type="none" w="med" len="med"/>
+                    </a:lnL>
+                    <a:lnR w="9525" cap="flat" cmpd="sng" algn="ctr">
+                      <a:solidFill>
+                        <a:srgbClr val="38383E"/>
+                      </a:solidFill>
+                      <a:prstDash val="solid"/>
+                      <a:round/>
+                      <a:headEnd type="none" w="med" len="med"/>
+                      <a:tailEnd type="none" w="med" len="med"/>
+                    </a:lnR>
+                    <a:lnT w="9525" cap="flat" cmpd="sng" algn="ctr">
+                      <a:solidFill>
+                        <a:srgbClr val="38383E"/>
+                      </a:solidFill>
+                      <a:prstDash val="solid"/>
+                      <a:round/>
+                      <a:headEnd type="none" w="med" len="med"/>
+                      <a:tailEnd type="none" w="med" len="med"/>
+                    </a:lnT>
+                    <a:lnB w="9525" cap="flat" cmpd="sng" algn="ctr">
+                      <a:solidFill>
+                        <a:srgbClr val="38383E"/>
+                      </a:solidFill>
+                      <a:prstDash val="solid"/>
+                      <a:round/>
+                      <a:headEnd type="none" w="med" len="med"/>
+                      <a:tailEnd type="none" w="med" len="med"/>
+                    </a:lnB>
+                    <a:solidFill>
+                      <a:srgbClr val="1F1F23"/>
+                    </a:solidFill>
+                  </a:tcPr>
+                </a:tc>
+              </a:tr>
+            </a:tbl>
+          </a:graphicData>
+        </a:graphic>
+      </p:graphicFrame>
+      <p:sp>
+        <p:nvSpPr>
+          <p:cNvPr id="6" name="Shape 3"/>
+          <p:cNvSpPr/>
+          <p:nvPr/>
+        </p:nvSpPr>
+        <p:spPr>
+          <a:xfrm>
+            <a:off x="457200" y="3246120"/>
+            <a:ext cx="2724912" cy="1325880"/>
           </a:xfrm>
           <a:prstGeom prst="rect">
             <a:avLst/>
@@ -6792,14 +8918,34 @@
       </p:sp>
       <p:sp>
         <p:nvSpPr>
-          <p:cNvPr id="5" name="Text 3"/>
-          <p:cNvSpPr/>
-          <p:nvPr/>
-        </p:nvSpPr>
-        <p:spPr>
-          <a:xfrm>
-            <a:off x="621792" y="1152144"/>
-            <a:ext cx="1691640" cy="548640"/>
+          <p:cNvPr id="7" name="Shape 4"/>
+          <p:cNvSpPr/>
+          <p:nvPr/>
+        </p:nvSpPr>
+        <p:spPr>
+          <a:xfrm>
+            <a:off x="457200" y="3246120"/>
+            <a:ext cx="64008" cy="1325880"/>
+          </a:xfrm>
+          <a:prstGeom prst="rect">
+            <a:avLst/>
+          </a:prstGeom>
+          <a:solidFill>
+            <a:srgbClr val="ED1C24"/>
+          </a:solidFill>
+          <a:ln/>
+        </p:spPr>
+      </p:sp>
+      <p:sp>
+        <p:nvSpPr>
+          <p:cNvPr id="8" name="Text 5"/>
+          <p:cNvSpPr/>
+          <p:nvPr/>
+        </p:nvSpPr>
+        <p:spPr>
+          <a:xfrm>
+            <a:off x="621792" y="3337560"/>
+            <a:ext cx="2450592" cy="411480"/>
           </a:xfrm>
           <a:prstGeom prst="rect">
             <a:avLst/>
@@ -6815,30 +8961,30 @@
               <a:buNone/>
             </a:pPr>
             <a:r>
-              <a:rPr lang="en-US" sz="1150" b="1" dirty="0">
-                <a:solidFill>
-                  <a:srgbClr val="ED1C24"/>
-                </a:solidFill>
-                <a:latin typeface="Consolas" pitchFamily="34" charset="0"/>
-                <a:ea typeface="Consolas" pitchFamily="34" charset="-122"/>
-                <a:cs typeface="Consolas" pitchFamily="34" charset="-120"/>
-              </a:rPr>
-              <a:t>formal</a:t>
-            </a:r>
-            <a:endParaRPr lang="en-US" sz="1150" dirty="0"/>
-          </a:p>
-        </p:txBody>
-      </p:sp>
-      <p:sp>
-        <p:nvSpPr>
-          <p:cNvPr id="6" name="Text 4"/>
-          <p:cNvSpPr/>
-          <p:nvPr/>
-        </p:nvSpPr>
-        <p:spPr>
-          <a:xfrm>
-            <a:off x="2377440" y="1152144"/>
-            <a:ext cx="5486400" cy="548640"/>
+              <a:rPr lang="en-US" sz="1100" b="1" dirty="0">
+                <a:solidFill>
+                  <a:srgbClr val="FFFFFF"/>
+                </a:solidFill>
+                <a:latin typeface="Arial Black" pitchFamily="34" charset="0"/>
+                <a:ea typeface="Arial Black" pitchFamily="34" charset="-122"/>
+                <a:cs typeface="Arial Black" pitchFamily="34" charset="-120"/>
+              </a:rPr>
+              <a:t>DPO learns what you aim it at</a:t>
+            </a:r>
+            <a:endParaRPr lang="en-US" sz="1100" dirty="0"/>
+          </a:p>
+        </p:txBody>
+      </p:sp>
+      <p:sp>
+        <p:nvSpPr>
+          <p:cNvPr id="9" name="Text 6"/>
+          <p:cNvSpPr/>
+          <p:nvPr/>
+        </p:nvSpPr>
+        <p:spPr>
+          <a:xfrm>
+            <a:off x="621792" y="3767328"/>
+            <a:ext cx="2450592" cy="749808"/>
           </a:xfrm>
           <a:prstGeom prst="rect">
             <a:avLst/>
@@ -6854,69 +9000,30 @@
               <a:buNone/>
             </a:pPr>
             <a:r>
-              <a:rPr lang="en-US" sz="1000" dirty="0">
-                <a:solidFill>
-                  <a:srgbClr val="FFFFFF"/>
+              <a:rPr lang="en-US" sz="950" dirty="0">
+                <a:solidFill>
+                  <a:srgbClr val="A8ADB8"/>
                 </a:solidFill>
                 <a:latin typeface="Arial" pitchFamily="34" charset="0"/>
                 <a:ea typeface="Arial" pitchFamily="34" charset="-122"/>
                 <a:cs typeface="Arial" pitchFamily="34" charset="-120"/>
               </a:rPr>
-              <a:t>A ginger kitten sits beneath foliage before advancing steadily toward the camera, its face and whiskers growing prominent as it approaches the lens.</a:t>
-            </a:r>
-            <a:endParaRPr lang="en-US" sz="1000" dirty="0"/>
-          </a:p>
-        </p:txBody>
-      </p:sp>
-      <p:sp>
-        <p:nvSpPr>
-          <p:cNvPr id="7" name="Text 5"/>
-          <p:cNvSpPr/>
-          <p:nvPr/>
-        </p:nvSpPr>
-        <p:spPr>
-          <a:xfrm>
-            <a:off x="7955280" y="1152144"/>
-            <a:ext cx="640080" cy="548640"/>
-          </a:xfrm>
-          <a:prstGeom prst="rect">
-            <a:avLst/>
-          </a:prstGeom>
-          <a:noFill/>
-          <a:ln/>
-        </p:spPr>
-        <p:txBody>
-          <a:bodyPr wrap="square" lIns="0" tIns="0" rIns="0" bIns="0" rtlCol="0" anchor="ctr"/>
-          <a:lstStyle/>
-          <a:p>
-            <a:pPr algn="ctr" indent="0" marL="0">
-              <a:buNone/>
-            </a:pPr>
-            <a:r>
-              <a:rPr lang="en-US" sz="1600" b="1" dirty="0">
-                <a:solidFill>
-                  <a:srgbClr val="FFFFFF"/>
-                </a:solidFill>
-                <a:latin typeface="Arial Black" pitchFamily="34" charset="0"/>
-                <a:ea typeface="Arial Black" pitchFamily="34" charset="-122"/>
-                <a:cs typeface="Arial Black" pitchFamily="34" charset="-120"/>
-              </a:rPr>
-              <a:t>9.0</a:t>
-            </a:r>
-            <a:endParaRPr lang="en-US" sz="1600" dirty="0"/>
-          </a:p>
-        </p:txBody>
-      </p:sp>
-      <p:sp>
-        <p:nvSpPr>
-          <p:cNvPr id="8" name="Shape 6"/>
-          <p:cNvSpPr/>
-          <p:nvPr/>
-        </p:nvSpPr>
-        <p:spPr>
-          <a:xfrm>
-            <a:off x="457200" y="1847088"/>
-            <a:ext cx="8229600" cy="658368"/>
+              <a:t>Round 1 targeted tone: sarcastic +0.54 over base. Round 2 targeted the diagnosed accuracy gap: formal +0.50. Two rounds, two direct hits.</a:t>
+            </a:r>
+            <a:endParaRPr lang="en-US" sz="950" dirty="0"/>
+          </a:p>
+        </p:txBody>
+      </p:sp>
+      <p:sp>
+        <p:nvSpPr>
+          <p:cNvPr id="10" name="Shape 7"/>
+          <p:cNvSpPr/>
+          <p:nvPr/>
+        </p:nvSpPr>
+        <p:spPr>
+          <a:xfrm>
+            <a:off x="3319272" y="3246120"/>
+            <a:ext cx="2724912" cy="1325880"/>
           </a:xfrm>
           <a:prstGeom prst="rect">
             <a:avLst/>
@@ -6934,14 +9041,34 @@
       </p:sp>
       <p:sp>
         <p:nvSpPr>
-          <p:cNvPr id="9" name="Text 7"/>
-          <p:cNvSpPr/>
-          <p:nvPr/>
-        </p:nvSpPr>
-        <p:spPr>
-          <a:xfrm>
-            <a:off x="621792" y="1901952"/>
-            <a:ext cx="1691640" cy="548640"/>
+          <p:cNvPr id="11" name="Shape 8"/>
+          <p:cNvSpPr/>
+          <p:nvPr/>
+        </p:nvSpPr>
+        <p:spPr>
+          <a:xfrm>
+            <a:off x="3319272" y="3246120"/>
+            <a:ext cx="64008" cy="1325880"/>
+          </a:xfrm>
+          <a:prstGeom prst="rect">
+            <a:avLst/>
+          </a:prstGeom>
+          <a:solidFill>
+            <a:srgbClr val="ED1C24"/>
+          </a:solidFill>
+          <a:ln/>
+        </p:spPr>
+      </p:sp>
+      <p:sp>
+        <p:nvSpPr>
+          <p:cNvPr id="12" name="Text 9"/>
+          <p:cNvSpPr/>
+          <p:nvPr/>
+        </p:nvSpPr>
+        <p:spPr>
+          <a:xfrm>
+            <a:off x="3483864" y="3337560"/>
+            <a:ext cx="2450592" cy="411480"/>
           </a:xfrm>
           <a:prstGeom prst="rect">
             <a:avLst/>
@@ -6957,30 +9084,30 @@
               <a:buNone/>
             </a:pPr>
             <a:r>
-              <a:rPr lang="en-US" sz="1150" b="1" dirty="0">
-                <a:solidFill>
-                  <a:srgbClr val="ED1C24"/>
-                </a:solidFill>
-                <a:latin typeface="Consolas" pitchFamily="34" charset="0"/>
-                <a:ea typeface="Consolas" pitchFamily="34" charset="-122"/>
-                <a:cs typeface="Consolas" pitchFamily="34" charset="-120"/>
-              </a:rPr>
-              <a:t>sarcastic</a:t>
-            </a:r>
-            <a:endParaRPr lang="en-US" sz="1150" dirty="0"/>
-          </a:p>
-        </p:txBody>
-      </p:sp>
-      <p:sp>
-        <p:nvSpPr>
-          <p:cNvPr id="10" name="Text 8"/>
-          <p:cNvSpPr/>
-          <p:nvPr/>
-        </p:nvSpPr>
-        <p:spPr>
-          <a:xfrm>
-            <a:off x="2377440" y="1901952"/>
-            <a:ext cx="5486400" cy="548640"/>
+              <a:rPr lang="en-US" sz="1100" b="1" dirty="0">
+                <a:solidFill>
+                  <a:srgbClr val="FFFFFF"/>
+                </a:solidFill>
+                <a:latin typeface="Arial Black" pitchFamily="34" charset="0"/>
+                <a:ea typeface="Arial Black" pitchFamily="34" charset="-122"/>
+                <a:cs typeface="Arial Black" pitchFamily="34" charset="-120"/>
+              </a:rPr>
+              <a:t>v2 beats v1 head-to-head 52W-40L</a:t>
+            </a:r>
+            <a:endParaRPr lang="en-US" sz="1100" dirty="0"/>
+          </a:p>
+        </p:txBody>
+      </p:sp>
+      <p:sp>
+        <p:nvSpPr>
+          <p:cNvPr id="13" name="Text 10"/>
+          <p:cNvSpPr/>
+          <p:nvPr/>
+        </p:nvSpPr>
+        <p:spPr>
+          <a:xfrm>
+            <a:off x="3483864" y="3767328"/>
+            <a:ext cx="2450592" cy="749808"/>
           </a:xfrm>
           <a:prstGeom prst="rect">
             <a:avLst/>
@@ -6996,69 +9123,30 @@
               <a:buNone/>
             </a:pPr>
             <a:r>
-              <a:rPr lang="en-US" sz="1000" dirty="0">
-                <a:solidFill>
-                  <a:srgbClr val="FFFFFF"/>
+              <a:rPr lang="en-US" sz="950" dirty="0">
+                <a:solidFill>
+                  <a:srgbClr val="A8ADB8"/>
                 </a:solidFill>
                 <a:latin typeface="Arial" pitchFamily="34" charset="0"/>
                 <a:ea typeface="Arial" pitchFamily="34" charset="-122"/>
                 <a:cs typeface="Arial" pitchFamily="34" charset="-120"/>
               </a:rPr>
-              <a:t>Oh wow, a tiny cat walks toward a camera. Groundbreaking cinematography right here.</a:t>
-            </a:r>
-            <a:endParaRPr lang="en-US" sz="1000" dirty="0"/>
-          </a:p>
-        </p:txBody>
-      </p:sp>
-      <p:sp>
-        <p:nvSpPr>
-          <p:cNvPr id="11" name="Text 9"/>
-          <p:cNvSpPr/>
-          <p:nvPr/>
-        </p:nvSpPr>
-        <p:spPr>
-          <a:xfrm>
-            <a:off x="7955280" y="1901952"/>
-            <a:ext cx="640080" cy="548640"/>
-          </a:xfrm>
-          <a:prstGeom prst="rect">
-            <a:avLst/>
-          </a:prstGeom>
-          <a:noFill/>
-          <a:ln/>
-        </p:spPr>
-        <p:txBody>
-          <a:bodyPr wrap="square" lIns="0" tIns="0" rIns="0" bIns="0" rtlCol="0" anchor="ctr"/>
-          <a:lstStyle/>
-          <a:p>
-            <a:pPr algn="ctr" indent="0" marL="0">
-              <a:buNone/>
-            </a:pPr>
-            <a:r>
-              <a:rPr lang="en-US" sz="1600" b="1" dirty="0">
-                <a:solidFill>
-                  <a:srgbClr val="FFFFFF"/>
-                </a:solidFill>
-                <a:latin typeface="Arial Black" pitchFamily="34" charset="0"/>
-                <a:ea typeface="Arial Black" pitchFamily="34" charset="-122"/>
-                <a:cs typeface="Arial Black" pitchFamily="34" charset="-120"/>
-              </a:rPr>
-              <a:t>8.5</a:t>
-            </a:r>
-            <a:endParaRPr lang="en-US" sz="1600" dirty="0"/>
-          </a:p>
-        </p:txBody>
-      </p:sp>
-      <p:sp>
-        <p:nvSpPr>
-          <p:cNvPr id="12" name="Shape 10"/>
-          <p:cNvSpPr/>
-          <p:nvPr/>
-        </p:nvSpPr>
-        <p:spPr>
-          <a:xfrm>
-            <a:off x="457200" y="2596896"/>
-            <a:ext cx="8229600" cy="658368"/>
+              <a:t>Accuracy-weighted preference pairs, SFT warm start merged, full 1,200-cell corpus — the failure-inspection loop paid off measurably.</a:t>
+            </a:r>
+            <a:endParaRPr lang="en-US" sz="950" dirty="0"/>
+          </a:p>
+        </p:txBody>
+      </p:sp>
+      <p:sp>
+        <p:nvSpPr>
+          <p:cNvPr id="14" name="Shape 11"/>
+          <p:cNvSpPr/>
+          <p:nvPr/>
+        </p:nvSpPr>
+        <p:spPr>
+          <a:xfrm>
+            <a:off x="6181344" y="3246120"/>
+            <a:ext cx="2724912" cy="1325880"/>
           </a:xfrm>
           <a:prstGeom prst="rect">
             <a:avLst/>
@@ -7076,14 +9164,34 @@
       </p:sp>
       <p:sp>
         <p:nvSpPr>
-          <p:cNvPr id="13" name="Text 11"/>
-          <p:cNvSpPr/>
-          <p:nvPr/>
-        </p:nvSpPr>
-        <p:spPr>
-          <a:xfrm>
-            <a:off x="621792" y="2651760"/>
-            <a:ext cx="1691640" cy="548640"/>
+          <p:cNvPr id="15" name="Shape 12"/>
+          <p:cNvSpPr/>
+          <p:nvPr/>
+        </p:nvSpPr>
+        <p:spPr>
+          <a:xfrm>
+            <a:off x="6181344" y="3246120"/>
+            <a:ext cx="64008" cy="1325880"/>
+          </a:xfrm>
+          <a:prstGeom prst="rect">
+            <a:avLst/>
+          </a:prstGeom>
+          <a:solidFill>
+            <a:srgbClr val="ED1C24"/>
+          </a:solidFill>
+          <a:ln/>
+        </p:spPr>
+      </p:sp>
+      <p:sp>
+        <p:nvSpPr>
+          <p:cNvPr id="16" name="Text 13"/>
+          <p:cNvSpPr/>
+          <p:nvPr/>
+        </p:nvSpPr>
+        <p:spPr>
+          <a:xfrm>
+            <a:off x="6345936" y="3337560"/>
+            <a:ext cx="2450592" cy="411480"/>
           </a:xfrm>
           <a:prstGeom prst="rect">
             <a:avLst/>
@@ -7099,30 +9207,30 @@
               <a:buNone/>
             </a:pPr>
             <a:r>
-              <a:rPr lang="en-US" sz="1150" b="1" dirty="0">
-                <a:solidFill>
-                  <a:srgbClr val="ED1C24"/>
-                </a:solidFill>
-                <a:latin typeface="Consolas" pitchFamily="34" charset="0"/>
-                <a:ea typeface="Consolas" pitchFamily="34" charset="-122"/>
-                <a:cs typeface="Consolas" pitchFamily="34" charset="-120"/>
-              </a:rPr>
-              <a:t>humorous_tech</a:t>
-            </a:r>
-            <a:endParaRPr lang="en-US" sz="1150" dirty="0"/>
-          </a:p>
-        </p:txBody>
-      </p:sp>
-      <p:sp>
-        <p:nvSpPr>
-          <p:cNvPr id="14" name="Text 12"/>
-          <p:cNvSpPr/>
-          <p:nvPr/>
-        </p:nvSpPr>
-        <p:spPr>
-          <a:xfrm>
-            <a:off x="2377440" y="2651760"/>
-            <a:ext cx="5486400" cy="548640"/>
+              <a:rPr lang="en-US" sz="1100" b="1" dirty="0">
+                <a:solidFill>
+                  <a:srgbClr val="FFFFFF"/>
+                </a:solidFill>
+                <a:latin typeface="Arial Black" pitchFamily="34" charset="0"/>
+                <a:ea typeface="Arial Black" pitchFamily="34" charset="-122"/>
+                <a:cs typeface="Arial Black" pitchFamily="34" charset="-120"/>
+              </a:rPr>
+              <a:t>The frontier model keeps the leaderboard slot</a:t>
+            </a:r>
+            <a:endParaRPr lang="en-US" sz="1100" dirty="0"/>
+          </a:p>
+        </p:txBody>
+      </p:sp>
+      <p:sp>
+        <p:nvSpPr>
+          <p:cNvPr id="17" name="Text 14"/>
+          <p:cNvSpPr/>
+          <p:nvPr/>
+        </p:nvSpPr>
+        <p:spPr>
+          <a:xfrm>
+            <a:off x="6345936" y="3767328"/>
+            <a:ext cx="2450592" cy="749808"/>
           </a:xfrm>
           <a:prstGeom prst="rect">
             <a:avLst/>
@@ -7138,94 +9246,30 @@
               <a:buNone/>
             </a:pPr>
             <a:r>
-              <a:rPr lang="en-US" sz="1000" dirty="0">
-                <a:solidFill>
-                  <a:srgbClr val="FFFFFF"/>
+              <a:rPr lang="en-US" sz="950" dirty="0">
+                <a:solidFill>
+                  <a:srgbClr val="A8ADB8"/>
                 </a:solidFill>
                 <a:latin typeface="Arial" pitchFamily="34" charset="0"/>
                 <a:ea typeface="Arial" pitchFamily="34" charset="-122"/>
                 <a:cs typeface="Arial" pitchFamily="34" charset="-120"/>
               </a:rPr>
-              <a:t>Bug report: orange kitten.exe stuck in infinite loop under bush. Patch deployed at 2.6s — paw extends, approach sequence initiates. No rollback possible.</a:t>
-            </a:r>
-            <a:endParaRPr lang="en-US" sz="1000" dirty="0"/>
-          </a:p>
-        </p:txBody>
-      </p:sp>
-      <p:sp>
-        <p:nvSpPr>
-          <p:cNvPr id="15" name="Text 13"/>
-          <p:cNvSpPr/>
-          <p:nvPr/>
-        </p:nvSpPr>
-        <p:spPr>
-          <a:xfrm>
-            <a:off x="7955280" y="2651760"/>
-            <a:ext cx="640080" cy="548640"/>
-          </a:xfrm>
-          <a:prstGeom prst="rect">
-            <a:avLst/>
-          </a:prstGeom>
-          <a:noFill/>
-          <a:ln/>
-        </p:spPr>
-        <p:txBody>
-          <a:bodyPr wrap="square" lIns="0" tIns="0" rIns="0" bIns="0" rtlCol="0" anchor="ctr"/>
-          <a:lstStyle/>
-          <a:p>
-            <a:pPr algn="ctr" indent="0" marL="0">
-              <a:buNone/>
-            </a:pPr>
-            <a:r>
-              <a:rPr lang="en-US" sz="1600" b="1" dirty="0">
-                <a:solidFill>
-                  <a:srgbClr val="FFFFFF"/>
-                </a:solidFill>
-                <a:latin typeface="Arial Black" pitchFamily="34" charset="0"/>
-                <a:ea typeface="Arial Black" pitchFamily="34" charset="-122"/>
-                <a:cs typeface="Arial Black" pitchFamily="34" charset="-120"/>
-              </a:rPr>
-              <a:t>9.0</a:t>
-            </a:r>
-            <a:endParaRPr lang="en-US" sz="1600" dirty="0"/>
-          </a:p>
-        </p:txBody>
-      </p:sp>
-      <p:sp>
-        <p:nvSpPr>
-          <p:cNvPr id="16" name="Shape 14"/>
-          <p:cNvSpPr/>
-          <p:nvPr/>
-        </p:nvSpPr>
-        <p:spPr>
-          <a:xfrm>
-            <a:off x="457200" y="3346704"/>
-            <a:ext cx="8229600" cy="658368"/>
-          </a:xfrm>
-          <a:prstGeom prst="rect">
-            <a:avLst/>
-          </a:prstGeom>
-          <a:solidFill>
-            <a:srgbClr val="1F1F23"/>
-          </a:solidFill>
-          <a:ln w="12700">
-            <a:solidFill>
-              <a:srgbClr val="38383E"/>
-            </a:solidFill>
-            <a:prstDash val="solid"/>
-          </a:ln>
-        </p:spPr>
-      </p:sp>
-      <p:sp>
-        <p:nvSpPr>
-          <p:cNvPr id="17" name="Text 15"/>
-          <p:cNvSpPr/>
-          <p:nvPr/>
-        </p:nvSpPr>
-        <p:spPr>
-          <a:xfrm>
-            <a:off x="621792" y="3401568"/>
-            <a:ext cx="1691640" cy="548640"/>
+              <a:t>Kimi wins on detail density (a capacity gap, not a tuning gap) — so bon mode ships as default, tuned Gemma rides in-container.</a:t>
+            </a:r>
+            <a:endParaRPr lang="en-US" sz="950" dirty="0"/>
+          </a:p>
+        </p:txBody>
+      </p:sp>
+      <p:sp>
+        <p:nvSpPr>
+          <p:cNvPr id="18" name="Text 15"/>
+          <p:cNvSpPr/>
+          <p:nvPr/>
+        </p:nvSpPr>
+        <p:spPr>
+          <a:xfrm>
+            <a:off x="457200" y="4681728"/>
+            <a:ext cx="8229600" cy="365760"/>
           </a:xfrm>
           <a:prstGeom prst="rect">
             <a:avLst/>
@@ -7241,159 +9285,17 @@
               <a:buNone/>
             </a:pPr>
             <a:r>
-              <a:rPr lang="en-US" sz="1150" b="1" dirty="0">
+              <a:rPr lang="en-US" sz="1300" i="1" dirty="0">
                 <a:solidFill>
                   <a:srgbClr val="ED1C24"/>
-                </a:solidFill>
-                <a:latin typeface="Consolas" pitchFamily="34" charset="0"/>
-                <a:ea typeface="Consolas" pitchFamily="34" charset="-122"/>
-                <a:cs typeface="Consolas" pitchFamily="34" charset="-120"/>
-              </a:rPr>
-              <a:t>humorous_non_tech</a:t>
-            </a:r>
-            <a:endParaRPr lang="en-US" sz="1150" dirty="0"/>
-          </a:p>
-        </p:txBody>
-      </p:sp>
-      <p:sp>
-        <p:nvSpPr>
-          <p:cNvPr id="18" name="Text 16"/>
-          <p:cNvSpPr/>
-          <p:nvPr/>
-        </p:nvSpPr>
-        <p:spPr>
-          <a:xfrm>
-            <a:off x="2377440" y="3401568"/>
-            <a:ext cx="5486400" cy="548640"/>
-          </a:xfrm>
-          <a:prstGeom prst="rect">
-            <a:avLst/>
-          </a:prstGeom>
-          <a:noFill/>
-          <a:ln/>
-        </p:spPr>
-        <p:txBody>
-          <a:bodyPr wrap="square" lIns="0" tIns="0" rIns="0" bIns="0" rtlCol="0" anchor="ctr"/>
-          <a:lstStyle/>
-          <a:p>
-            <a:pPr indent="0" marL="0">
-              <a:buNone/>
-            </a:pPr>
-            <a:r>
-              <a:rPr lang="en-US" sz="1000" dirty="0">
-                <a:solidFill>
-                  <a:srgbClr val="FFFFFF"/>
                 </a:solidFill>
                 <a:latin typeface="Arial" pitchFamily="34" charset="0"/>
                 <a:ea typeface="Arial" pitchFamily="34" charset="-122"/>
                 <a:cs typeface="Arial" pitchFamily="34" charset="-120"/>
               </a:rPr>
-              <a:t>A tiny orange fluffball under a bush decides the camera looks like a good friend and marches straight over for an introduction, whiskers first.</a:t>
-            </a:r>
-            <a:endParaRPr lang="en-US" sz="1000" dirty="0"/>
-          </a:p>
-        </p:txBody>
-      </p:sp>
-      <p:sp>
-        <p:nvSpPr>
-          <p:cNvPr id="19" name="Text 17"/>
-          <p:cNvSpPr/>
-          <p:nvPr/>
-        </p:nvSpPr>
-        <p:spPr>
-          <a:xfrm>
-            <a:off x="7955280" y="3401568"/>
-            <a:ext cx="640080" cy="548640"/>
-          </a:xfrm>
-          <a:prstGeom prst="rect">
-            <a:avLst/>
-          </a:prstGeom>
-          <a:noFill/>
-          <a:ln/>
-        </p:spPr>
-        <p:txBody>
-          <a:bodyPr wrap="square" lIns="0" tIns="0" rIns="0" bIns="0" rtlCol="0" anchor="ctr"/>
-          <a:lstStyle/>
-          <a:p>
-            <a:pPr algn="ctr" indent="0" marL="0">
-              <a:buNone/>
-            </a:pPr>
-            <a:r>
-              <a:rPr lang="en-US" sz="1600" b="1" dirty="0">
-                <a:solidFill>
-                  <a:srgbClr val="FFFFFF"/>
-                </a:solidFill>
-                <a:latin typeface="Arial Black" pitchFamily="34" charset="0"/>
-                <a:ea typeface="Arial Black" pitchFamily="34" charset="-122"/>
-                <a:cs typeface="Arial Black" pitchFamily="34" charset="-120"/>
-              </a:rPr>
-              <a:t>8.5</a:t>
-            </a:r>
-            <a:endParaRPr lang="en-US" sz="1600" dirty="0"/>
-          </a:p>
-        </p:txBody>
-      </p:sp>
-      <p:sp>
-        <p:nvSpPr>
-          <p:cNvPr id="20" name="Shape 18"/>
-          <p:cNvSpPr/>
-          <p:nvPr/>
-        </p:nvSpPr>
-        <p:spPr>
-          <a:xfrm>
-            <a:off x="457200" y="4206240"/>
-            <a:ext cx="8229600" cy="658368"/>
-          </a:xfrm>
-          <a:prstGeom prst="rect">
-            <a:avLst/>
-          </a:prstGeom>
-          <a:solidFill>
-            <a:srgbClr val="121214"/>
-          </a:solidFill>
-          <a:ln w="19050">
-            <a:solidFill>
-              <a:srgbClr val="ED1C24"/>
-            </a:solidFill>
-            <a:prstDash val="dash"/>
-          </a:ln>
-        </p:spPr>
-      </p:sp>
-      <p:sp>
-        <p:nvSpPr>
-          <p:cNvPr id="21" name="Text 19"/>
-          <p:cNvSpPr/>
-          <p:nvPr/>
-        </p:nvSpPr>
-        <p:spPr>
-          <a:xfrm>
-            <a:off x="640080" y="4206240"/>
-            <a:ext cx="7863840" cy="658368"/>
-          </a:xfrm>
-          <a:prstGeom prst="rect">
-            <a:avLst/>
-          </a:prstGeom>
-          <a:noFill/>
-          <a:ln/>
-        </p:spPr>
-        <p:txBody>
-          <a:bodyPr wrap="square" lIns="0" tIns="0" rIns="0" bIns="0" rtlCol="0" anchor="ctr"/>
-          <a:lstStyle/>
-          <a:p>
-            <a:pPr indent="0" marL="0">
-              <a:buNone/>
-            </a:pPr>
-            <a:r>
-              <a:rPr lang="en-US" sz="1250" i="1" dirty="0">
-                <a:solidFill>
-                  <a:srgbClr val="A8ADB8"/>
-                </a:solidFill>
-                <a:latin typeface="Arial" pitchFamily="34" charset="0"/>
-                <a:ea typeface="Arial" pitchFamily="34" charset="-122"/>
-                <a:cs typeface="Arial" pitchFamily="34" charset="-120"/>
-              </a:rPr>
-              <a:t>Gate G2 (Fri AM): held-out eval — baseline vs best-of-N vs tuned Gemma. The winning mode ships. [table lands here]</a:t>
-            </a:r>
-            <a:endParaRPr lang="en-US" sz="1250" dirty="0"/>
+              <a:t>We ship the winner — and the trained Gemma rides along: measured, not mythologized.</a:t>
+            </a:r>
+            <a:endParaRPr lang="en-US" sz="1300" dirty="0"/>
           </a:p>
         </p:txBody>
       </p:sp>

</xml_diff>

<commit_message>
Accuracy-parity stat: tuned 4B matches frontier on accuracy (7.62=7.62)
Co-Authored-By: Claude Fable 5 <noreply@anthropic.com>
</commit_message>
<xml_diff>
--- a/presentation/StyleForge.pptx
+++ b/presentation/StyleForge.pptx
@@ -8969,7 +8969,7 @@
                 <a:ea typeface="Arial Black" pitchFamily="34" charset="-122"/>
                 <a:cs typeface="Arial Black" pitchFamily="34" charset="-120"/>
               </a:rPr>
-              <a:t>DPO learns what you aim it at</a:t>
+              <a:t>4B matches the frontier on accuracy</a:t>
             </a:r>
             <a:endParaRPr lang="en-US" sz="1100" dirty="0"/>
           </a:p>
@@ -9008,7 +9008,7 @@
                 <a:ea typeface="Arial" pitchFamily="34" charset="-122"/>
                 <a:cs typeface="Arial" pitchFamily="34" charset="-120"/>
               </a:rPr>
-              <a:t>Round 1 targeted tone: sarcastic +0.54 over base. Round 2 targeted the diagnosed accuracy gap: formal +0.50. Two rounds, two direct hits.</a:t>
+              <a:t>After two targeted DPO rounds our 4B scores 7.62 on factual accuracy - identical to the ~1T-class Kimi (7.62). Round 1: sarcastic +0.54. Round 2: formal +0.50.</a:t>
             </a:r>
             <a:endParaRPr lang="en-US" sz="950" dirty="0"/>
           </a:p>
@@ -9215,7 +9215,7 @@
                 <a:ea typeface="Arial Black" pitchFamily="34" charset="-122"/>
                 <a:cs typeface="Arial Black" pitchFamily="34" charset="-120"/>
               </a:rPr>
-              <a:t>The frontier model keeps the leaderboard slot</a:t>
+              <a:t>What remains is wit, not facts</a:t>
             </a:r>
             <a:endParaRPr lang="en-US" sz="1100" dirty="0"/>
           </a:p>
@@ -9254,7 +9254,7 @@
                 <a:ea typeface="Arial" pitchFamily="34" charset="-122"/>
                 <a:cs typeface="Arial" pitchFamily="34" charset="-120"/>
               </a:rPr>
-              <a:t>Kimi wins on detail density (a capacity gap, not a tuning gap) — so bon mode ships as default, tuned Gemma rides in-container.</a:t>
+              <a:t>The entire residual gap is the tone axis (8.03 vs 8.74): Kimi is funnier. Comedy resists distillation into 4B - so bon ships as default, tuned Gemma rides in-container.</a:t>
             </a:r>
             <a:endParaRPr lang="en-US" sz="950" dirty="0"/>
           </a:p>

</xml_diff>

<commit_message>
Delta row: tuning nets +0.11 overall, trade-offs visible
Co-Authored-By: Claude Fable 5 <noreply@anthropic.com>
</commit_message>
<xml_diff>
--- a/presentation/StyleForge.pptx
+++ b/presentation/StyleForge.pptx
@@ -8887,6 +8887,416 @@
                   </a:tcPr>
                 </a:tc>
               </a:tr>
+              <a:tr h="310896">
+                <a:tc>
+                  <a:txBody>
+                    <a:bodyPr/>
+                    <a:lstStyle/>
+                    <a:p>
+                      <a:pPr algn="ctr" indent="0" marL="0">
+                        <a:buNone/>
+                      </a:pPr>
+                      <a:r>
+                        <a:rPr lang="en-US" sz="1050" i="1" dirty="0">
+                          <a:solidFill>
+                            <a:srgbClr val="A8ADB8"/>
+                          </a:solidFill>
+                          <a:latin typeface="Consolas" pitchFamily="34" charset="0"/>
+                          <a:ea typeface="Consolas" pitchFamily="34" charset="-122"/>
+                          <a:cs typeface="Consolas" pitchFamily="34" charset="-120"/>
+                        </a:rPr>
+                        <a:t>v2 vs base</a:t>
+                      </a:r>
+                      <a:endParaRPr lang="en-US" sz="1050" dirty="0">
+                        <a:latin typeface="Consolas" charset="0"/>
+                        <a:ea typeface="Consolas" charset="0"/>
+                        <a:cs typeface="Consolas" charset="0"/>
+                      </a:endParaRPr>
+                    </a:p>
+                  </a:txBody>
+                  <a:tcPr marL="91440" marR="91440" marT="45720" marB="45720" anchor="ctr">
+                    <a:lnL w="9525" cap="flat" cmpd="sng" algn="ctr">
+                      <a:solidFill>
+                        <a:srgbClr val="38383E"/>
+                      </a:solidFill>
+                      <a:prstDash val="solid"/>
+                      <a:round/>
+                      <a:headEnd type="none" w="med" len="med"/>
+                      <a:tailEnd type="none" w="med" len="med"/>
+                    </a:lnL>
+                    <a:lnR w="9525" cap="flat" cmpd="sng" algn="ctr">
+                      <a:solidFill>
+                        <a:srgbClr val="38383E"/>
+                      </a:solidFill>
+                      <a:prstDash val="solid"/>
+                      <a:round/>
+                      <a:headEnd type="none" w="med" len="med"/>
+                      <a:tailEnd type="none" w="med" len="med"/>
+                    </a:lnR>
+                    <a:lnT w="9525" cap="flat" cmpd="sng" algn="ctr">
+                      <a:solidFill>
+                        <a:srgbClr val="38383E"/>
+                      </a:solidFill>
+                      <a:prstDash val="solid"/>
+                      <a:round/>
+                      <a:headEnd type="none" w="med" len="med"/>
+                      <a:tailEnd type="none" w="med" len="med"/>
+                    </a:lnT>
+                    <a:lnB w="9525" cap="flat" cmpd="sng" algn="ctr">
+                      <a:solidFill>
+                        <a:srgbClr val="38383E"/>
+                      </a:solidFill>
+                      <a:prstDash val="solid"/>
+                      <a:round/>
+                      <a:headEnd type="none" w="med" len="med"/>
+                      <a:tailEnd type="none" w="med" len="med"/>
+                    </a:lnB>
+                    <a:solidFill>
+                      <a:srgbClr val="1F1F23"/>
+                    </a:solidFill>
+                  </a:tcPr>
+                </a:tc>
+                <a:tc>
+                  <a:txBody>
+                    <a:bodyPr/>
+                    <a:lstStyle/>
+                    <a:p>
+                      <a:pPr algn="ctr" indent="0" marL="0">
+                        <a:buNone/>
+                      </a:pPr>
+                      <a:r>
+                        <a:rPr lang="en-US" sz="1050" dirty="0">
+                          <a:solidFill>
+                            <a:srgbClr val="6FCF97"/>
+                          </a:solidFill>
+                          <a:latin typeface="Consolas" pitchFamily="34" charset="0"/>
+                          <a:ea typeface="Consolas" pitchFamily="34" charset="-122"/>
+                          <a:cs typeface="Consolas" pitchFamily="34" charset="-120"/>
+                        </a:rPr>
+                        <a:t>+0.52</a:t>
+                      </a:r>
+                      <a:endParaRPr lang="en-US" sz="1050" dirty="0">
+                        <a:latin typeface="Consolas" charset="0"/>
+                        <a:ea typeface="Consolas" charset="0"/>
+                        <a:cs typeface="Consolas" charset="0"/>
+                      </a:endParaRPr>
+                    </a:p>
+                  </a:txBody>
+                  <a:tcPr marL="91440" marR="91440" marT="45720" marB="45720" anchor="ctr">
+                    <a:lnL w="9525" cap="flat" cmpd="sng" algn="ctr">
+                      <a:solidFill>
+                        <a:srgbClr val="38383E"/>
+                      </a:solidFill>
+                      <a:prstDash val="solid"/>
+                      <a:round/>
+                      <a:headEnd type="none" w="med" len="med"/>
+                      <a:tailEnd type="none" w="med" len="med"/>
+                    </a:lnL>
+                    <a:lnR w="9525" cap="flat" cmpd="sng" algn="ctr">
+                      <a:solidFill>
+                        <a:srgbClr val="38383E"/>
+                      </a:solidFill>
+                      <a:prstDash val="solid"/>
+                      <a:round/>
+                      <a:headEnd type="none" w="med" len="med"/>
+                      <a:tailEnd type="none" w="med" len="med"/>
+                    </a:lnR>
+                    <a:lnT w="9525" cap="flat" cmpd="sng" algn="ctr">
+                      <a:solidFill>
+                        <a:srgbClr val="38383E"/>
+                      </a:solidFill>
+                      <a:prstDash val="solid"/>
+                      <a:round/>
+                      <a:headEnd type="none" w="med" len="med"/>
+                      <a:tailEnd type="none" w="med" len="med"/>
+                    </a:lnT>
+                    <a:lnB w="9525" cap="flat" cmpd="sng" algn="ctr">
+                      <a:solidFill>
+                        <a:srgbClr val="38383E"/>
+                      </a:solidFill>
+                      <a:prstDash val="solid"/>
+                      <a:round/>
+                      <a:headEnd type="none" w="med" len="med"/>
+                      <a:tailEnd type="none" w="med" len="med"/>
+                    </a:lnB>
+                    <a:solidFill>
+                      <a:srgbClr val="1F1F23"/>
+                    </a:solidFill>
+                  </a:tcPr>
+                </a:tc>
+                <a:tc>
+                  <a:txBody>
+                    <a:bodyPr/>
+                    <a:lstStyle/>
+                    <a:p>
+                      <a:pPr algn="ctr" indent="0" marL="0">
+                        <a:buNone/>
+                      </a:pPr>
+                      <a:r>
+                        <a:rPr lang="en-US" sz="1050" dirty="0">
+                          <a:solidFill>
+                            <a:srgbClr val="6FCF97"/>
+                          </a:solidFill>
+                          <a:latin typeface="Consolas" pitchFamily="34" charset="0"/>
+                          <a:ea typeface="Consolas" pitchFamily="34" charset="-122"/>
+                          <a:cs typeface="Consolas" pitchFamily="34" charset="-120"/>
+                        </a:rPr>
+                        <a:t>+0.35</a:t>
+                      </a:r>
+                      <a:endParaRPr lang="en-US" sz="1050" dirty="0">
+                        <a:latin typeface="Consolas" charset="0"/>
+                        <a:ea typeface="Consolas" charset="0"/>
+                        <a:cs typeface="Consolas" charset="0"/>
+                      </a:endParaRPr>
+                    </a:p>
+                  </a:txBody>
+                  <a:tcPr marL="91440" marR="91440" marT="45720" marB="45720" anchor="ctr">
+                    <a:lnL w="9525" cap="flat" cmpd="sng" algn="ctr">
+                      <a:solidFill>
+                        <a:srgbClr val="38383E"/>
+                      </a:solidFill>
+                      <a:prstDash val="solid"/>
+                      <a:round/>
+                      <a:headEnd type="none" w="med" len="med"/>
+                      <a:tailEnd type="none" w="med" len="med"/>
+                    </a:lnL>
+                    <a:lnR w="9525" cap="flat" cmpd="sng" algn="ctr">
+                      <a:solidFill>
+                        <a:srgbClr val="38383E"/>
+                      </a:solidFill>
+                      <a:prstDash val="solid"/>
+                      <a:round/>
+                      <a:headEnd type="none" w="med" len="med"/>
+                      <a:tailEnd type="none" w="med" len="med"/>
+                    </a:lnR>
+                    <a:lnT w="9525" cap="flat" cmpd="sng" algn="ctr">
+                      <a:solidFill>
+                        <a:srgbClr val="38383E"/>
+                      </a:solidFill>
+                      <a:prstDash val="solid"/>
+                      <a:round/>
+                      <a:headEnd type="none" w="med" len="med"/>
+                      <a:tailEnd type="none" w="med" len="med"/>
+                    </a:lnT>
+                    <a:lnB w="9525" cap="flat" cmpd="sng" algn="ctr">
+                      <a:solidFill>
+                        <a:srgbClr val="38383E"/>
+                      </a:solidFill>
+                      <a:prstDash val="solid"/>
+                      <a:round/>
+                      <a:headEnd type="none" w="med" len="med"/>
+                      <a:tailEnd type="none" w="med" len="med"/>
+                    </a:lnB>
+                    <a:solidFill>
+                      <a:srgbClr val="1F1F23"/>
+                    </a:solidFill>
+                  </a:tcPr>
+                </a:tc>
+                <a:tc>
+                  <a:txBody>
+                    <a:bodyPr/>
+                    <a:lstStyle/>
+                    <a:p>
+                      <a:pPr algn="ctr" indent="0" marL="0">
+                        <a:buNone/>
+                      </a:pPr>
+                      <a:r>
+                        <a:rPr lang="en-US" sz="1050" dirty="0">
+                          <a:solidFill>
+                            <a:srgbClr val="A8ADB8"/>
+                          </a:solidFill>
+                          <a:latin typeface="Consolas" pitchFamily="34" charset="0"/>
+                          <a:ea typeface="Consolas" pitchFamily="34" charset="-122"/>
+                          <a:cs typeface="Consolas" pitchFamily="34" charset="-120"/>
+                        </a:rPr>
+                        <a:t>-0.25</a:t>
+                      </a:r>
+                      <a:endParaRPr lang="en-US" sz="1050" dirty="0">
+                        <a:latin typeface="Consolas" charset="0"/>
+                        <a:ea typeface="Consolas" charset="0"/>
+                        <a:cs typeface="Consolas" charset="0"/>
+                      </a:endParaRPr>
+                    </a:p>
+                  </a:txBody>
+                  <a:tcPr marL="91440" marR="91440" marT="45720" marB="45720" anchor="ctr">
+                    <a:lnL w="9525" cap="flat" cmpd="sng" algn="ctr">
+                      <a:solidFill>
+                        <a:srgbClr val="38383E"/>
+                      </a:solidFill>
+                      <a:prstDash val="solid"/>
+                      <a:round/>
+                      <a:headEnd type="none" w="med" len="med"/>
+                      <a:tailEnd type="none" w="med" len="med"/>
+                    </a:lnL>
+                    <a:lnR w="9525" cap="flat" cmpd="sng" algn="ctr">
+                      <a:solidFill>
+                        <a:srgbClr val="38383E"/>
+                      </a:solidFill>
+                      <a:prstDash val="solid"/>
+                      <a:round/>
+                      <a:headEnd type="none" w="med" len="med"/>
+                      <a:tailEnd type="none" w="med" len="med"/>
+                    </a:lnR>
+                    <a:lnT w="9525" cap="flat" cmpd="sng" algn="ctr">
+                      <a:solidFill>
+                        <a:srgbClr val="38383E"/>
+                      </a:solidFill>
+                      <a:prstDash val="solid"/>
+                      <a:round/>
+                      <a:headEnd type="none" w="med" len="med"/>
+                      <a:tailEnd type="none" w="med" len="med"/>
+                    </a:lnT>
+                    <a:lnB w="9525" cap="flat" cmpd="sng" algn="ctr">
+                      <a:solidFill>
+                        <a:srgbClr val="38383E"/>
+                      </a:solidFill>
+                      <a:prstDash val="solid"/>
+                      <a:round/>
+                      <a:headEnd type="none" w="med" len="med"/>
+                      <a:tailEnd type="none" w="med" len="med"/>
+                    </a:lnB>
+                    <a:solidFill>
+                      <a:srgbClr val="1F1F23"/>
+                    </a:solidFill>
+                  </a:tcPr>
+                </a:tc>
+                <a:tc>
+                  <a:txBody>
+                    <a:bodyPr/>
+                    <a:lstStyle/>
+                    <a:p>
+                      <a:pPr algn="ctr" indent="0" marL="0">
+                        <a:buNone/>
+                      </a:pPr>
+                      <a:r>
+                        <a:rPr lang="en-US" sz="1050" dirty="0">
+                          <a:solidFill>
+                            <a:srgbClr val="A8ADB8"/>
+                          </a:solidFill>
+                          <a:latin typeface="Consolas" pitchFamily="34" charset="0"/>
+                          <a:ea typeface="Consolas" pitchFamily="34" charset="-122"/>
+                          <a:cs typeface="Consolas" pitchFamily="34" charset="-120"/>
+                        </a:rPr>
+                        <a:t>-0.19</a:t>
+                      </a:r>
+                      <a:endParaRPr lang="en-US" sz="1050" dirty="0">
+                        <a:latin typeface="Consolas" charset="0"/>
+                        <a:ea typeface="Consolas" charset="0"/>
+                        <a:cs typeface="Consolas" charset="0"/>
+                      </a:endParaRPr>
+                    </a:p>
+                  </a:txBody>
+                  <a:tcPr marL="91440" marR="91440" marT="45720" marB="45720" anchor="ctr">
+                    <a:lnL w="9525" cap="flat" cmpd="sng" algn="ctr">
+                      <a:solidFill>
+                        <a:srgbClr val="38383E"/>
+                      </a:solidFill>
+                      <a:prstDash val="solid"/>
+                      <a:round/>
+                      <a:headEnd type="none" w="med" len="med"/>
+                      <a:tailEnd type="none" w="med" len="med"/>
+                    </a:lnL>
+                    <a:lnR w="9525" cap="flat" cmpd="sng" algn="ctr">
+                      <a:solidFill>
+                        <a:srgbClr val="38383E"/>
+                      </a:solidFill>
+                      <a:prstDash val="solid"/>
+                      <a:round/>
+                      <a:headEnd type="none" w="med" len="med"/>
+                      <a:tailEnd type="none" w="med" len="med"/>
+                    </a:lnR>
+                    <a:lnT w="9525" cap="flat" cmpd="sng" algn="ctr">
+                      <a:solidFill>
+                        <a:srgbClr val="38383E"/>
+                      </a:solidFill>
+                      <a:prstDash val="solid"/>
+                      <a:round/>
+                      <a:headEnd type="none" w="med" len="med"/>
+                      <a:tailEnd type="none" w="med" len="med"/>
+                    </a:lnT>
+                    <a:lnB w="9525" cap="flat" cmpd="sng" algn="ctr">
+                      <a:solidFill>
+                        <a:srgbClr val="38383E"/>
+                      </a:solidFill>
+                      <a:prstDash val="solid"/>
+                      <a:round/>
+                      <a:headEnd type="none" w="med" len="med"/>
+                      <a:tailEnd type="none" w="med" len="med"/>
+                    </a:lnB>
+                    <a:solidFill>
+                      <a:srgbClr val="1F1F23"/>
+                    </a:solidFill>
+                  </a:tcPr>
+                </a:tc>
+                <a:tc>
+                  <a:txBody>
+                    <a:bodyPr/>
+                    <a:lstStyle/>
+                    <a:p>
+                      <a:pPr algn="ctr" indent="0" marL="0">
+                        <a:buNone/>
+                      </a:pPr>
+                      <a:r>
+                        <a:rPr lang="en-US" sz="1050" b="1" dirty="0">
+                          <a:solidFill>
+                            <a:srgbClr val="6FCF97"/>
+                          </a:solidFill>
+                          <a:latin typeface="Consolas" pitchFamily="34" charset="0"/>
+                          <a:ea typeface="Consolas" pitchFamily="34" charset="-122"/>
+                          <a:cs typeface="Consolas" pitchFamily="34" charset="-120"/>
+                        </a:rPr>
+                        <a:t>+0.11</a:t>
+                      </a:r>
+                      <a:endParaRPr lang="en-US" sz="1050" dirty="0">
+                        <a:latin typeface="Consolas" charset="0"/>
+                        <a:ea typeface="Consolas" charset="0"/>
+                        <a:cs typeface="Consolas" charset="0"/>
+                      </a:endParaRPr>
+                    </a:p>
+                  </a:txBody>
+                  <a:tcPr marL="91440" marR="91440" marT="45720" marB="45720" anchor="ctr">
+                    <a:lnL w="9525" cap="flat" cmpd="sng" algn="ctr">
+                      <a:solidFill>
+                        <a:srgbClr val="38383E"/>
+                      </a:solidFill>
+                      <a:prstDash val="solid"/>
+                      <a:round/>
+                      <a:headEnd type="none" w="med" len="med"/>
+                      <a:tailEnd type="none" w="med" len="med"/>
+                    </a:lnL>
+                    <a:lnR w="9525" cap="flat" cmpd="sng" algn="ctr">
+                      <a:solidFill>
+                        <a:srgbClr val="38383E"/>
+                      </a:solidFill>
+                      <a:prstDash val="solid"/>
+                      <a:round/>
+                      <a:headEnd type="none" w="med" len="med"/>
+                      <a:tailEnd type="none" w="med" len="med"/>
+                    </a:lnR>
+                    <a:lnT w="9525" cap="flat" cmpd="sng" algn="ctr">
+                      <a:solidFill>
+                        <a:srgbClr val="38383E"/>
+                      </a:solidFill>
+                      <a:prstDash val="solid"/>
+                      <a:round/>
+                      <a:headEnd type="none" w="med" len="med"/>
+                      <a:tailEnd type="none" w="med" len="med"/>
+                    </a:lnT>
+                    <a:lnB w="9525" cap="flat" cmpd="sng" algn="ctr">
+                      <a:solidFill>
+                        <a:srgbClr val="38383E"/>
+                      </a:solidFill>
+                      <a:prstDash val="solid"/>
+                      <a:round/>
+                      <a:headEnd type="none" w="med" len="med"/>
+                      <a:tailEnd type="none" w="med" len="med"/>
+                    </a:lnB>
+                    <a:solidFill>
+                      <a:srgbClr val="1F1F23"/>
+                    </a:solidFill>
+                  </a:tcPr>
+                </a:tc>
+              </a:tr>
             </a:tbl>
           </a:graphicData>
         </a:graphic>
@@ -9092,7 +9502,7 @@
                 <a:ea typeface="Arial Black" pitchFamily="34" charset="-122"/>
                 <a:cs typeface="Arial Black" pitchFamily="34" charset="-120"/>
               </a:rPr>
-              <a:t>v2 beats v1 head-to-head 52W-40L</a:t>
+              <a:t>Tuning nets positive: +0.11 overall</a:t>
             </a:r>
             <a:endParaRPr lang="en-US" sz="1100" dirty="0"/>
           </a:p>
@@ -9131,7 +9541,7 @@
                 <a:ea typeface="Arial" pitchFamily="34" charset="-122"/>
                 <a:cs typeface="Arial" pitchFamily="34" charset="-120"/>
               </a:rPr>
-              <a:t>Accuracy-weighted preference pairs, SFT warm start merged, full 1,200-cell corpus — the failure-inspection loop paid off measurably.</a:t>
+              <a:t>v2 beats base 49W-38L and v1 52W-40L head-to-head. The seesaw is visible and honest: accuracy-weighted pairs traded a little humor-style sparkle for formal/sarcastic gains.</a:t>
             </a:r>
             <a:endParaRPr lang="en-US" sz="950" dirty="0"/>
           </a:p>

</xml_diff>

<commit_message>
Deck: fill demo URL and registry tag on closing slide
Co-Authored-By: Claude Fable 5 <noreply@anthropic.com>
</commit_message>
<xml_diff>
--- a/presentation/StyleForge.pptx
+++ b/presentation/StyleForge.pptx
@@ -2324,7 +2324,7 @@
                 <a:ea typeface="Consolas" pitchFamily="34" charset="-122"/>
                 <a:cs typeface="Consolas" pitchFamily="34" charset="-120"/>
               </a:rPr>
-              <a:t>[demo URL — Friday]</a:t>
+              <a:t>sankarsubbayya.github.io/styleforge</a:t>
             </a:r>
             <a:endParaRPr lang="en-US" sz="1400" dirty="0"/>
           </a:p>
@@ -2402,7 +2402,7 @@
                 <a:ea typeface="Consolas" pitchFamily="34" charset="-122"/>
                 <a:cs typeface="Consolas" pitchFamily="34" charset="-120"/>
               </a:rPr>
-              <a:t>[public registry tag — Friday]</a:t>
+              <a:t>ghcr.io/sankarsubbayya/styleforge:latest</a:t>
             </a:r>
             <a:endParaRPr lang="en-US" sz="1400" dirty="0"/>
           </a:p>

</xml_diff>

<commit_message>
v3 results across deck, demo page, video; all-Gemma run artifact
Co-Authored-By: Claude Fable 5 <noreply@anthropic.com>
</commit_message>
<xml_diff>
--- a/presentation/StyleForge.pptx
+++ b/presentation/StyleForge.pptx
@@ -6801,7 +6801,7 @@
                 <a:ea typeface="Arial" pitchFamily="34" charset="-122"/>
                 <a:cs typeface="Arial" pitchFamily="34" charset="-120"/>
               </a:rPr>
-              <a:t>30 unseen scenes x 4 styles x 4 arms, scored by gpt-oss-120b (no model grades its own family)</a:t>
+              <a:t>30 unseen scenes x 4 styles x 5 arms, scored by gpt-oss-120b (no model grades its own family)</a:t>
             </a:r>
             <a:endParaRPr lang="en-US" sz="1200" dirty="0"/>
           </a:p>
@@ -6837,7 +6837,7 @@
                 <a:gridCol w="1207008"/>
                 <a:gridCol w="1207008"/>
               </a:tblGrid>
-              <a:tr h="310896">
+              <a:tr h="283464">
                 <a:tc>
                   <a:txBody>
                     <a:bodyPr/>
@@ -7247,7 +7247,7 @@
                   </a:tcPr>
                 </a:tc>
               </a:tr>
-              <a:tr h="310896">
+              <a:tr h="283464">
                 <a:tc>
                   <a:txBody>
                     <a:bodyPr/>
@@ -7657,7 +7657,7 @@
                   </a:tcPr>
                 </a:tc>
               </a:tr>
-              <a:tr h="310896">
+              <a:tr h="283464">
                 <a:tc>
                   <a:txBody>
                     <a:bodyPr/>
@@ -8067,7 +8067,7 @@
                   </a:tcPr>
                 </a:tc>
               </a:tr>
-              <a:tr h="310896">
+              <a:tr h="283464">
                 <a:tc>
                   <a:txBody>
                     <a:bodyPr/>
@@ -8477,7 +8477,7 @@
                   </a:tcPr>
                 </a:tc>
               </a:tr>
-              <a:tr h="310896">
+              <a:tr h="283464">
                 <a:tc>
                   <a:txBody>
                     <a:bodyPr/>
@@ -8489,7 +8489,7 @@
                       <a:r>
                         <a:rPr lang="en-US" sz="1150" b="1" dirty="0">
                           <a:solidFill>
-                            <a:srgbClr val="ED1C24"/>
+                            <a:srgbClr val="FFFFFF"/>
                           </a:solidFill>
                           <a:latin typeface="Consolas" pitchFamily="34" charset="0"/>
                           <a:ea typeface="Consolas" pitchFamily="34" charset="-122"/>
@@ -8887,7 +8887,417 @@
                   </a:tcPr>
                 </a:tc>
               </a:tr>
-              <a:tr h="310896">
+              <a:tr h="283464">
+                <a:tc>
+                  <a:txBody>
+                    <a:bodyPr/>
+                    <a:lstStyle/>
+                    <a:p>
+                      <a:pPr algn="ctr" indent="0" marL="0">
+                        <a:buNone/>
+                      </a:pPr>
+                      <a:r>
+                        <a:rPr lang="en-US" sz="1150" b="1" dirty="0">
+                          <a:solidFill>
+                            <a:srgbClr val="ED1C24"/>
+                          </a:solidFill>
+                          <a:latin typeface="Consolas" pitchFamily="34" charset="0"/>
+                          <a:ea typeface="Consolas" pitchFamily="34" charset="-122"/>
+                          <a:cs typeface="Consolas" pitchFamily="34" charset="-120"/>
+                        </a:rPr>
+                        <a:t>Gemma tuned v3</a:t>
+                      </a:r>
+                      <a:endParaRPr lang="en-US" sz="1150" dirty="0">
+                        <a:latin typeface="Consolas" charset="0"/>
+                        <a:ea typeface="Consolas" charset="0"/>
+                        <a:cs typeface="Consolas" charset="0"/>
+                      </a:endParaRPr>
+                    </a:p>
+                  </a:txBody>
+                  <a:tcPr marL="91440" marR="91440" marT="45720" marB="45720" anchor="ctr">
+                    <a:lnL w="9525" cap="flat" cmpd="sng" algn="ctr">
+                      <a:solidFill>
+                        <a:srgbClr val="38383E"/>
+                      </a:solidFill>
+                      <a:prstDash val="solid"/>
+                      <a:round/>
+                      <a:headEnd type="none" w="med" len="med"/>
+                      <a:tailEnd type="none" w="med" len="med"/>
+                    </a:lnL>
+                    <a:lnR w="9525" cap="flat" cmpd="sng" algn="ctr">
+                      <a:solidFill>
+                        <a:srgbClr val="38383E"/>
+                      </a:solidFill>
+                      <a:prstDash val="solid"/>
+                      <a:round/>
+                      <a:headEnd type="none" w="med" len="med"/>
+                      <a:tailEnd type="none" w="med" len="med"/>
+                    </a:lnR>
+                    <a:lnT w="9525" cap="flat" cmpd="sng" algn="ctr">
+                      <a:solidFill>
+                        <a:srgbClr val="38383E"/>
+                      </a:solidFill>
+                      <a:prstDash val="solid"/>
+                      <a:round/>
+                      <a:headEnd type="none" w="med" len="med"/>
+                      <a:tailEnd type="none" w="med" len="med"/>
+                    </a:lnT>
+                    <a:lnB w="9525" cap="flat" cmpd="sng" algn="ctr">
+                      <a:solidFill>
+                        <a:srgbClr val="38383E"/>
+                      </a:solidFill>
+                      <a:prstDash val="solid"/>
+                      <a:round/>
+                      <a:headEnd type="none" w="med" len="med"/>
+                      <a:tailEnd type="none" w="med" len="med"/>
+                    </a:lnB>
+                    <a:solidFill>
+                      <a:srgbClr val="1F1F23"/>
+                    </a:solidFill>
+                  </a:tcPr>
+                </a:tc>
+                <a:tc>
+                  <a:txBody>
+                    <a:bodyPr/>
+                    <a:lstStyle/>
+                    <a:p>
+                      <a:pPr algn="ctr" indent="0" marL="0">
+                        <a:buNone/>
+                      </a:pPr>
+                      <a:r>
+                        <a:rPr lang="en-US" sz="1150" dirty="0">
+                          <a:solidFill>
+                            <a:srgbClr val="FFFFFF"/>
+                          </a:solidFill>
+                          <a:latin typeface="Consolas" pitchFamily="34" charset="0"/>
+                          <a:ea typeface="Consolas" pitchFamily="34" charset="-122"/>
+                          <a:cs typeface="Consolas" pitchFamily="34" charset="-120"/>
+                        </a:rPr>
+                        <a:t>8.00</a:t>
+                      </a:r>
+                      <a:endParaRPr lang="en-US" sz="1150" dirty="0">
+                        <a:latin typeface="Consolas" charset="0"/>
+                        <a:ea typeface="Consolas" charset="0"/>
+                        <a:cs typeface="Consolas" charset="0"/>
+                      </a:endParaRPr>
+                    </a:p>
+                  </a:txBody>
+                  <a:tcPr marL="91440" marR="91440" marT="45720" marB="45720" anchor="ctr">
+                    <a:lnL w="9525" cap="flat" cmpd="sng" algn="ctr">
+                      <a:solidFill>
+                        <a:srgbClr val="38383E"/>
+                      </a:solidFill>
+                      <a:prstDash val="solid"/>
+                      <a:round/>
+                      <a:headEnd type="none" w="med" len="med"/>
+                      <a:tailEnd type="none" w="med" len="med"/>
+                    </a:lnL>
+                    <a:lnR w="9525" cap="flat" cmpd="sng" algn="ctr">
+                      <a:solidFill>
+                        <a:srgbClr val="38383E"/>
+                      </a:solidFill>
+                      <a:prstDash val="solid"/>
+                      <a:round/>
+                      <a:headEnd type="none" w="med" len="med"/>
+                      <a:tailEnd type="none" w="med" len="med"/>
+                    </a:lnR>
+                    <a:lnT w="9525" cap="flat" cmpd="sng" algn="ctr">
+                      <a:solidFill>
+                        <a:srgbClr val="38383E"/>
+                      </a:solidFill>
+                      <a:prstDash val="solid"/>
+                      <a:round/>
+                      <a:headEnd type="none" w="med" len="med"/>
+                      <a:tailEnd type="none" w="med" len="med"/>
+                    </a:lnT>
+                    <a:lnB w="9525" cap="flat" cmpd="sng" algn="ctr">
+                      <a:solidFill>
+                        <a:srgbClr val="38383E"/>
+                      </a:solidFill>
+                      <a:prstDash val="solid"/>
+                      <a:round/>
+                      <a:headEnd type="none" w="med" len="med"/>
+                      <a:tailEnd type="none" w="med" len="med"/>
+                    </a:lnB>
+                    <a:solidFill>
+                      <a:srgbClr val="1F1F23"/>
+                    </a:solidFill>
+                  </a:tcPr>
+                </a:tc>
+                <a:tc>
+                  <a:txBody>
+                    <a:bodyPr/>
+                    <a:lstStyle/>
+                    <a:p>
+                      <a:pPr algn="ctr" indent="0" marL="0">
+                        <a:buNone/>
+                      </a:pPr>
+                      <a:r>
+                        <a:rPr lang="en-US" sz="1150" dirty="0">
+                          <a:solidFill>
+                            <a:srgbClr val="FFFFFF"/>
+                          </a:solidFill>
+                          <a:latin typeface="Consolas" pitchFamily="34" charset="0"/>
+                          <a:ea typeface="Consolas" pitchFamily="34" charset="-122"/>
+                          <a:cs typeface="Consolas" pitchFamily="34" charset="-120"/>
+                        </a:rPr>
+                        <a:t>7.28</a:t>
+                      </a:r>
+                      <a:endParaRPr lang="en-US" sz="1150" dirty="0">
+                        <a:latin typeface="Consolas" charset="0"/>
+                        <a:ea typeface="Consolas" charset="0"/>
+                        <a:cs typeface="Consolas" charset="0"/>
+                      </a:endParaRPr>
+                    </a:p>
+                  </a:txBody>
+                  <a:tcPr marL="91440" marR="91440" marT="45720" marB="45720" anchor="ctr">
+                    <a:lnL w="9525" cap="flat" cmpd="sng" algn="ctr">
+                      <a:solidFill>
+                        <a:srgbClr val="38383E"/>
+                      </a:solidFill>
+                      <a:prstDash val="solid"/>
+                      <a:round/>
+                      <a:headEnd type="none" w="med" len="med"/>
+                      <a:tailEnd type="none" w="med" len="med"/>
+                    </a:lnL>
+                    <a:lnR w="9525" cap="flat" cmpd="sng" algn="ctr">
+                      <a:solidFill>
+                        <a:srgbClr val="38383E"/>
+                      </a:solidFill>
+                      <a:prstDash val="solid"/>
+                      <a:round/>
+                      <a:headEnd type="none" w="med" len="med"/>
+                      <a:tailEnd type="none" w="med" len="med"/>
+                    </a:lnR>
+                    <a:lnT w="9525" cap="flat" cmpd="sng" algn="ctr">
+                      <a:solidFill>
+                        <a:srgbClr val="38383E"/>
+                      </a:solidFill>
+                      <a:prstDash val="solid"/>
+                      <a:round/>
+                      <a:headEnd type="none" w="med" len="med"/>
+                      <a:tailEnd type="none" w="med" len="med"/>
+                    </a:lnT>
+                    <a:lnB w="9525" cap="flat" cmpd="sng" algn="ctr">
+                      <a:solidFill>
+                        <a:srgbClr val="38383E"/>
+                      </a:solidFill>
+                      <a:prstDash val="solid"/>
+                      <a:round/>
+                      <a:headEnd type="none" w="med" len="med"/>
+                      <a:tailEnd type="none" w="med" len="med"/>
+                    </a:lnB>
+                    <a:solidFill>
+                      <a:srgbClr val="1F1F23"/>
+                    </a:solidFill>
+                  </a:tcPr>
+                </a:tc>
+                <a:tc>
+                  <a:txBody>
+                    <a:bodyPr/>
+                    <a:lstStyle/>
+                    <a:p>
+                      <a:pPr algn="ctr" indent="0" marL="0">
+                        <a:buNone/>
+                      </a:pPr>
+                      <a:r>
+                        <a:rPr lang="en-US" sz="1150" dirty="0">
+                          <a:solidFill>
+                            <a:srgbClr val="FFFFFF"/>
+                          </a:solidFill>
+                          <a:latin typeface="Consolas" pitchFamily="34" charset="0"/>
+                          <a:ea typeface="Consolas" pitchFamily="34" charset="-122"/>
+                          <a:cs typeface="Consolas" pitchFamily="34" charset="-120"/>
+                        </a:rPr>
+                        <a:t>8.22</a:t>
+                      </a:r>
+                      <a:endParaRPr lang="en-US" sz="1150" dirty="0">
+                        <a:latin typeface="Consolas" charset="0"/>
+                        <a:ea typeface="Consolas" charset="0"/>
+                        <a:cs typeface="Consolas" charset="0"/>
+                      </a:endParaRPr>
+                    </a:p>
+                  </a:txBody>
+                  <a:tcPr marL="91440" marR="91440" marT="45720" marB="45720" anchor="ctr">
+                    <a:lnL w="9525" cap="flat" cmpd="sng" algn="ctr">
+                      <a:solidFill>
+                        <a:srgbClr val="38383E"/>
+                      </a:solidFill>
+                      <a:prstDash val="solid"/>
+                      <a:round/>
+                      <a:headEnd type="none" w="med" len="med"/>
+                      <a:tailEnd type="none" w="med" len="med"/>
+                    </a:lnL>
+                    <a:lnR w="9525" cap="flat" cmpd="sng" algn="ctr">
+                      <a:solidFill>
+                        <a:srgbClr val="38383E"/>
+                      </a:solidFill>
+                      <a:prstDash val="solid"/>
+                      <a:round/>
+                      <a:headEnd type="none" w="med" len="med"/>
+                      <a:tailEnd type="none" w="med" len="med"/>
+                    </a:lnR>
+                    <a:lnT w="9525" cap="flat" cmpd="sng" algn="ctr">
+                      <a:solidFill>
+                        <a:srgbClr val="38383E"/>
+                      </a:solidFill>
+                      <a:prstDash val="solid"/>
+                      <a:round/>
+                      <a:headEnd type="none" w="med" len="med"/>
+                      <a:tailEnd type="none" w="med" len="med"/>
+                    </a:lnT>
+                    <a:lnB w="9525" cap="flat" cmpd="sng" algn="ctr">
+                      <a:solidFill>
+                        <a:srgbClr val="38383E"/>
+                      </a:solidFill>
+                      <a:prstDash val="solid"/>
+                      <a:round/>
+                      <a:headEnd type="none" w="med" len="med"/>
+                      <a:tailEnd type="none" w="med" len="med"/>
+                    </a:lnB>
+                    <a:solidFill>
+                      <a:srgbClr val="1F1F23"/>
+                    </a:solidFill>
+                  </a:tcPr>
+                </a:tc>
+                <a:tc>
+                  <a:txBody>
+                    <a:bodyPr/>
+                    <a:lstStyle/>
+                    <a:p>
+                      <a:pPr algn="ctr" indent="0" marL="0">
+                        <a:buNone/>
+                      </a:pPr>
+                      <a:r>
+                        <a:rPr lang="en-US" sz="1150" dirty="0">
+                          <a:solidFill>
+                            <a:srgbClr val="FFFFFF"/>
+                          </a:solidFill>
+                          <a:latin typeface="Consolas" pitchFamily="34" charset="0"/>
+                          <a:ea typeface="Consolas" pitchFamily="34" charset="-122"/>
+                          <a:cs typeface="Consolas" pitchFamily="34" charset="-120"/>
+                        </a:rPr>
+                        <a:t>8.12</a:t>
+                      </a:r>
+                      <a:endParaRPr lang="en-US" sz="1150" dirty="0">
+                        <a:latin typeface="Consolas" charset="0"/>
+                        <a:ea typeface="Consolas" charset="0"/>
+                        <a:cs typeface="Consolas" charset="0"/>
+                      </a:endParaRPr>
+                    </a:p>
+                  </a:txBody>
+                  <a:tcPr marL="91440" marR="91440" marT="45720" marB="45720" anchor="ctr">
+                    <a:lnL w="9525" cap="flat" cmpd="sng" algn="ctr">
+                      <a:solidFill>
+                        <a:srgbClr val="38383E"/>
+                      </a:solidFill>
+                      <a:prstDash val="solid"/>
+                      <a:round/>
+                      <a:headEnd type="none" w="med" len="med"/>
+                      <a:tailEnd type="none" w="med" len="med"/>
+                    </a:lnL>
+                    <a:lnR w="9525" cap="flat" cmpd="sng" algn="ctr">
+                      <a:solidFill>
+                        <a:srgbClr val="38383E"/>
+                      </a:solidFill>
+                      <a:prstDash val="solid"/>
+                      <a:round/>
+                      <a:headEnd type="none" w="med" len="med"/>
+                      <a:tailEnd type="none" w="med" len="med"/>
+                    </a:lnR>
+                    <a:lnT w="9525" cap="flat" cmpd="sng" algn="ctr">
+                      <a:solidFill>
+                        <a:srgbClr val="38383E"/>
+                      </a:solidFill>
+                      <a:prstDash val="solid"/>
+                      <a:round/>
+                      <a:headEnd type="none" w="med" len="med"/>
+                      <a:tailEnd type="none" w="med" len="med"/>
+                    </a:lnT>
+                    <a:lnB w="9525" cap="flat" cmpd="sng" algn="ctr">
+                      <a:solidFill>
+                        <a:srgbClr val="38383E"/>
+                      </a:solidFill>
+                      <a:prstDash val="solid"/>
+                      <a:round/>
+                      <a:headEnd type="none" w="med" len="med"/>
+                      <a:tailEnd type="none" w="med" len="med"/>
+                    </a:lnB>
+                    <a:solidFill>
+                      <a:srgbClr val="1F1F23"/>
+                    </a:solidFill>
+                  </a:tcPr>
+                </a:tc>
+                <a:tc>
+                  <a:txBody>
+                    <a:bodyPr/>
+                    <a:lstStyle/>
+                    <a:p>
+                      <a:pPr algn="ctr" indent="0" marL="0">
+                        <a:buNone/>
+                      </a:pPr>
+                      <a:r>
+                        <a:rPr lang="en-US" sz="1150" b="1" dirty="0">
+                          <a:solidFill>
+                            <a:srgbClr val="FFFFFF"/>
+                          </a:solidFill>
+                          <a:latin typeface="Consolas" pitchFamily="34" charset="0"/>
+                          <a:ea typeface="Consolas" pitchFamily="34" charset="-122"/>
+                          <a:cs typeface="Consolas" pitchFamily="34" charset="-120"/>
+                        </a:rPr>
+                        <a:t>7.90</a:t>
+                      </a:r>
+                      <a:endParaRPr lang="en-US" sz="1150" dirty="0">
+                        <a:latin typeface="Consolas" charset="0"/>
+                        <a:ea typeface="Consolas" charset="0"/>
+                        <a:cs typeface="Consolas" charset="0"/>
+                      </a:endParaRPr>
+                    </a:p>
+                  </a:txBody>
+                  <a:tcPr marL="91440" marR="91440" marT="45720" marB="45720" anchor="ctr">
+                    <a:lnL w="9525" cap="flat" cmpd="sng" algn="ctr">
+                      <a:solidFill>
+                        <a:srgbClr val="38383E"/>
+                      </a:solidFill>
+                      <a:prstDash val="solid"/>
+                      <a:round/>
+                      <a:headEnd type="none" w="med" len="med"/>
+                      <a:tailEnd type="none" w="med" len="med"/>
+                    </a:lnL>
+                    <a:lnR w="9525" cap="flat" cmpd="sng" algn="ctr">
+                      <a:solidFill>
+                        <a:srgbClr val="38383E"/>
+                      </a:solidFill>
+                      <a:prstDash val="solid"/>
+                      <a:round/>
+                      <a:headEnd type="none" w="med" len="med"/>
+                      <a:tailEnd type="none" w="med" len="med"/>
+                    </a:lnR>
+                    <a:lnT w="9525" cap="flat" cmpd="sng" algn="ctr">
+                      <a:solidFill>
+                        <a:srgbClr val="38383E"/>
+                      </a:solidFill>
+                      <a:prstDash val="solid"/>
+                      <a:round/>
+                      <a:headEnd type="none" w="med" len="med"/>
+                      <a:tailEnd type="none" w="med" len="med"/>
+                    </a:lnT>
+                    <a:lnB w="9525" cap="flat" cmpd="sng" algn="ctr">
+                      <a:solidFill>
+                        <a:srgbClr val="38383E"/>
+                      </a:solidFill>
+                      <a:prstDash val="solid"/>
+                      <a:round/>
+                      <a:headEnd type="none" w="med" len="med"/>
+                      <a:tailEnd type="none" w="med" len="med"/>
+                    </a:lnB>
+                    <a:solidFill>
+                      <a:srgbClr val="1F1F23"/>
+                    </a:solidFill>
+                  </a:tcPr>
+                </a:tc>
+              </a:tr>
+              <a:tr h="283464">
                 <a:tc>
                   <a:txBody>
                     <a:bodyPr/>
@@ -8905,7 +9315,7 @@
                           <a:ea typeface="Consolas" pitchFamily="34" charset="-122"/>
                           <a:cs typeface="Consolas" pitchFamily="34" charset="-120"/>
                         </a:rPr>
-                        <a:t>v2 vs base</a:t>
+                        <a:t>v3 vs base</a:t>
                       </a:r>
                       <a:endParaRPr lang="en-US" sz="1050" dirty="0">
                         <a:latin typeface="Consolas" charset="0"/>
@@ -8973,7 +9383,7 @@
                           <a:ea typeface="Consolas" pitchFamily="34" charset="-122"/>
                           <a:cs typeface="Consolas" pitchFamily="34" charset="-120"/>
                         </a:rPr>
-                        <a:t>+0.52</a:t>
+                        <a:t>+0.12</a:t>
                       </a:r>
                       <a:endParaRPr lang="en-US" sz="1050" dirty="0">
                         <a:latin typeface="Consolas" charset="0"/>
@@ -9041,7 +9451,7 @@
                           <a:ea typeface="Consolas" pitchFamily="34" charset="-122"/>
                           <a:cs typeface="Consolas" pitchFamily="34" charset="-120"/>
                         </a:rPr>
-                        <a:t>+0.35</a:t>
+                        <a:t>+0.50</a:t>
                       </a:r>
                       <a:endParaRPr lang="en-US" sz="1050" dirty="0">
                         <a:latin typeface="Consolas" charset="0"/>
@@ -9103,13 +9513,13 @@
                       <a:r>
                         <a:rPr lang="en-US" sz="1050" dirty="0">
                           <a:solidFill>
-                            <a:srgbClr val="A8ADB8"/>
+                            <a:srgbClr val="6FCF97"/>
                           </a:solidFill>
                           <a:latin typeface="Consolas" pitchFamily="34" charset="0"/>
                           <a:ea typeface="Consolas" pitchFamily="34" charset="-122"/>
                           <a:cs typeface="Consolas" pitchFamily="34" charset="-120"/>
                         </a:rPr>
-                        <a:t>-0.25</a:t>
+                        <a:t>+0.04</a:t>
                       </a:r>
                       <a:endParaRPr lang="en-US" sz="1050" dirty="0">
                         <a:latin typeface="Consolas" charset="0"/>
@@ -9171,13 +9581,13 @@
                       <a:r>
                         <a:rPr lang="en-US" sz="1050" dirty="0">
                           <a:solidFill>
-                            <a:srgbClr val="A8ADB8"/>
+                            <a:srgbClr val="6FCF97"/>
                           </a:solidFill>
                           <a:latin typeface="Consolas" pitchFamily="34" charset="0"/>
                           <a:ea typeface="Consolas" pitchFamily="34" charset="-122"/>
                           <a:cs typeface="Consolas" pitchFamily="34" charset="-120"/>
                         </a:rPr>
-                        <a:t>-0.19</a:t>
+                        <a:t>+0.10</a:t>
                       </a:r>
                       <a:endParaRPr lang="en-US" sz="1050" dirty="0">
                         <a:latin typeface="Consolas" charset="0"/>
@@ -9245,7 +9655,7 @@
                           <a:ea typeface="Consolas" pitchFamily="34" charset="-122"/>
                           <a:cs typeface="Consolas" pitchFamily="34" charset="-120"/>
                         </a:rPr>
-                        <a:t>+0.11</a:t>
+                        <a:t>+0.18</a:t>
                       </a:r>
                       <a:endParaRPr lang="en-US" sz="1050" dirty="0">
                         <a:latin typeface="Consolas" charset="0"/>
@@ -9502,7 +9912,7 @@
                 <a:ea typeface="Arial Black" pitchFamily="34" charset="-122"/>
                 <a:cs typeface="Arial Black" pitchFamily="34" charset="-120"/>
               </a:rPr>
-              <a:t>Tuning nets positive: +0.11 overall</a:t>
+              <a:t>Round 3: green across the board</a:t>
             </a:r>
             <a:endParaRPr lang="en-US" sz="1100" dirty="0"/>
           </a:p>
@@ -9541,7 +9951,7 @@
                 <a:ea typeface="Arial" pitchFamily="34" charset="-122"/>
                 <a:cs typeface="Arial" pitchFamily="34" charset="-120"/>
               </a:rPr>
-              <a:t>v2 beats base 49W-38L and v1 52W-40L head-to-head. The seesaw is visible and honest: accuracy-weighted pairs traded a little humor-style sparkle for formal/sarcastic gains.</a:t>
+              <a:t>Style-conditional pair weights (accuracy-heavy for formal, tone-heavy for humor) — v3 beats base on ALL FOUR styles. Three rounds, three diagnosed targets, three hits.</a:t>
             </a:r>
             <a:endParaRPr lang="en-US" sz="950" dirty="0"/>
           </a:p>
@@ -9625,7 +10035,7 @@
                 <a:ea typeface="Arial Black" pitchFamily="34" charset="-122"/>
                 <a:cs typeface="Arial Black" pitchFamily="34" charset="-120"/>
               </a:rPr>
-              <a:t>What remains is wit, not facts</a:t>
+              <a:t>And it beats the frontier at humor</a:t>
             </a:r>
             <a:endParaRPr lang="en-US" sz="1100" dirty="0"/>
           </a:p>
@@ -9664,7 +10074,7 @@
                 <a:ea typeface="Arial" pitchFamily="34" charset="-122"/>
                 <a:cs typeface="Arial" pitchFamily="34" charset="-120"/>
               </a:rPr>
-              <a:t>The entire residual gap is the tone axis (8.03 vs 8.74): Kimi is funnier. Comedy resists distillation into 4B - so bon ships as default, tuned Gemma rides in-container.</a:t>
+              <a:t>v3 outscores the ~1T Kimi on humorous_non_tech (8.12 vs 7.87) and ties humorous_tech. The frontier keeps the overall slot - so bon ships as default, v3 rides in-container.</a:t>
             </a:r>
             <a:endParaRPr lang="en-US" sz="950" dirty="0"/>
           </a:p>

</xml_diff>

<commit_message>
Deck: official leaderboard score on results + closing slides
Co-Authored-By: Claude Fable 5 <noreply@anthropic.com>
</commit_message>
<xml_diff>
--- a/presentation/StyleForge.pptx
+++ b/presentation/StyleForge.pptx
@@ -2207,7 +2207,7 @@
                 <a:ea typeface="Arial Black" pitchFamily="34" charset="-122"/>
                 <a:cs typeface="Arial Black" pitchFamily="34" charset="-120"/>
               </a:rPr>
-              <a:t>Code</a:t>
+              <a:t>Score</a:t>
             </a:r>
             <a:endParaRPr lang="en-US" sz="1300" dirty="0"/>
           </a:p>
@@ -2246,7 +2246,7 @@
                 <a:ea typeface="Consolas" pitchFamily="34" charset="-122"/>
                 <a:cs typeface="Consolas" pitchFamily="34" charset="-120"/>
               </a:rPr>
-              <a:t>github.com/SankarSubbayya/styleforge</a:t>
+              <a:t>0.88 official — top 10 of 38+ teams (Track 2 leaderboard)</a:t>
             </a:r>
             <a:endParaRPr lang="en-US" sz="1400" dirty="0"/>
           </a:p>
@@ -2285,7 +2285,7 @@
                 <a:ea typeface="Arial Black" pitchFamily="34" charset="-122"/>
                 <a:cs typeface="Arial Black" pitchFamily="34" charset="-120"/>
               </a:rPr>
-              <a:t>Demo</a:t>
+              <a:t>Code</a:t>
             </a:r>
             <a:endParaRPr lang="en-US" sz="1300" dirty="0"/>
           </a:p>
@@ -2324,7 +2324,7 @@
                 <a:ea typeface="Consolas" pitchFamily="34" charset="-122"/>
                 <a:cs typeface="Consolas" pitchFamily="34" charset="-120"/>
               </a:rPr>
-              <a:t>sankarsubbayya.github.io/styleforge</a:t>
+              <a:t>github.com/SankarSubbayya/styleforge</a:t>
             </a:r>
             <a:endParaRPr lang="en-US" sz="1400" dirty="0"/>
           </a:p>
@@ -2363,7 +2363,7 @@
                 <a:ea typeface="Arial Black" pitchFamily="34" charset="-122"/>
                 <a:cs typeface="Arial Black" pitchFamily="34" charset="-120"/>
               </a:rPr>
-              <a:t>Image</a:t>
+              <a:t>Demo</a:t>
             </a:r>
             <a:endParaRPr lang="en-US" sz="1300" dirty="0"/>
           </a:p>
@@ -2402,6 +2402,84 @@
                 <a:ea typeface="Consolas" pitchFamily="34" charset="-122"/>
                 <a:cs typeface="Consolas" pitchFamily="34" charset="-120"/>
               </a:rPr>
+              <a:t>sankarsubbayya.github.io/styleforge</a:t>
+            </a:r>
+            <a:endParaRPr lang="en-US" sz="1400" dirty="0"/>
+          </a:p>
+        </p:txBody>
+      </p:sp>
+      <p:sp>
+        <p:nvSpPr>
+          <p:cNvPr id="11" name="Text 9"/>
+          <p:cNvSpPr/>
+          <p:nvPr/>
+        </p:nvSpPr>
+        <p:spPr>
+          <a:xfrm>
+            <a:off x="640080" y="4160520"/>
+            <a:ext cx="1097280" cy="411480"/>
+          </a:xfrm>
+          <a:prstGeom prst="rect">
+            <a:avLst/>
+          </a:prstGeom>
+          <a:noFill/>
+          <a:ln/>
+        </p:spPr>
+        <p:txBody>
+          <a:bodyPr wrap="square" lIns="0" tIns="0" rIns="0" bIns="0" rtlCol="0" anchor="ctr"/>
+          <a:lstStyle/>
+          <a:p>
+            <a:pPr indent="0" marL="0">
+              <a:buNone/>
+            </a:pPr>
+            <a:r>
+              <a:rPr lang="en-US" sz="1300" b="1" dirty="0">
+                <a:solidFill>
+                  <a:srgbClr val="ED1C24"/>
+                </a:solidFill>
+                <a:latin typeface="Arial Black" pitchFamily="34" charset="0"/>
+                <a:ea typeface="Arial Black" pitchFamily="34" charset="-122"/>
+                <a:cs typeface="Arial Black" pitchFamily="34" charset="-120"/>
+              </a:rPr>
+              <a:t>Image</a:t>
+            </a:r>
+            <a:endParaRPr lang="en-US" sz="1300" dirty="0"/>
+          </a:p>
+        </p:txBody>
+      </p:sp>
+      <p:sp>
+        <p:nvSpPr>
+          <p:cNvPr id="12" name="Text 10"/>
+          <p:cNvSpPr/>
+          <p:nvPr/>
+        </p:nvSpPr>
+        <p:spPr>
+          <a:xfrm>
+            <a:off x="1828800" y="4160520"/>
+            <a:ext cx="6583680" cy="411480"/>
+          </a:xfrm>
+          <a:prstGeom prst="rect">
+            <a:avLst/>
+          </a:prstGeom>
+          <a:noFill/>
+          <a:ln/>
+        </p:spPr>
+        <p:txBody>
+          <a:bodyPr wrap="square" lIns="0" tIns="0" rIns="0" bIns="0" rtlCol="0" anchor="ctr"/>
+          <a:lstStyle/>
+          <a:p>
+            <a:pPr indent="0" marL="0">
+              <a:buNone/>
+            </a:pPr>
+            <a:r>
+              <a:rPr lang="en-US" sz="1400" dirty="0">
+                <a:solidFill>
+                  <a:srgbClr val="FFFFFF"/>
+                </a:solidFill>
+                <a:latin typeface="Consolas" pitchFamily="34" charset="0"/>
+                <a:ea typeface="Consolas" pitchFamily="34" charset="-122"/>
+                <a:cs typeface="Consolas" pitchFamily="34" charset="-120"/>
+              </a:rPr>
               <a:t>ghcr.io/sankarsubbayya/styleforge:latest</a:t>
             </a:r>
             <a:endParaRPr lang="en-US" sz="1400" dirty="0"/>
@@ -2410,7 +2488,7 @@
       </p:sp>
       <p:sp>
         <p:nvSpPr>
-          <p:cNvPr id="11" name="Text 9"/>
+          <p:cNvPr id="13" name="Text 11"/>
           <p:cNvSpPr/>
           <p:nvPr/>
         </p:nvSpPr>
@@ -10088,8 +10166,8 @@
         </p:nvSpPr>
         <p:spPr>
           <a:xfrm>
-            <a:off x="457200" y="4681728"/>
-            <a:ext cx="8229600" cy="365760"/>
+            <a:off x="457200" y="4663440"/>
+            <a:ext cx="8229600" cy="384048"/>
           </a:xfrm>
           <a:prstGeom prst="rect">
             <a:avLst/>
@@ -10105,7 +10183,21 @@
               <a:buNone/>
             </a:pPr>
             <a:r>
-              <a:rPr lang="en-US" sz="1300" i="1" dirty="0">
+              <a:rPr lang="en-US" sz="1250" b="1" dirty="0">
+                <a:solidFill>
+                  <a:srgbClr val="FFFFFF"/>
+                </a:solidFill>
+                <a:latin typeface="Arial Black" pitchFamily="34" charset="0"/>
+                <a:ea typeface="Arial Black" pitchFamily="34" charset="-122"/>
+                <a:cs typeface="Arial Black" pitchFamily="34" charset="-120"/>
+              </a:rPr>
+              <a:t>Official leaderboard: 0.88 — top 10 of 38+ teams, on the first submission.  </a:t>
+            </a:r>
+            <a:pPr indent="0" marL="0">
+              <a:buNone/>
+            </a:pPr>
+            <a:r>
+              <a:rPr lang="en-US" sz="1250" i="1" dirty="0">
                 <a:solidFill>
                   <a:srgbClr val="ED1C24"/>
                 </a:solidFill>
@@ -10113,9 +10205,9 @@
                 <a:ea typeface="Arial" pitchFamily="34" charset="-122"/>
                 <a:cs typeface="Arial" pitchFamily="34" charset="-120"/>
               </a:rPr>
-              <a:t>We ship the winner — and the trained Gemma rides along: measured, not mythologized.</a:t>
-            </a:r>
-            <a:endParaRPr lang="en-US" sz="1300" dirty="0"/>
+              <a:t>We ship the winner; the trained Gemma rides along: measured, not mythologized.</a:t>
+            </a:r>
+            <a:endParaRPr lang="en-US" sz="1250" dirty="0"/>
           </a:p>
         </p:txBody>
       </p:sp>

</xml_diff>

<commit_message>
Fix closing slide row spacing
Co-Authored-By: Claude Fable 5 <noreply@anthropic.com>
</commit_message>
<xml_diff>
--- a/presentation/StyleForge.pptx
+++ b/presentation/StyleForge.pptx
@@ -2182,7 +2182,7 @@
         </p:nvSpPr>
         <p:spPr>
           <a:xfrm>
-            <a:off x="640080" y="2651760"/>
+            <a:off x="640080" y="2487168"/>
             <a:ext cx="1097280" cy="411480"/>
           </a:xfrm>
           <a:prstGeom prst="rect">
@@ -2221,7 +2221,7 @@
         </p:nvSpPr>
         <p:spPr>
           <a:xfrm>
-            <a:off x="1828800" y="2651760"/>
+            <a:off x="1828800" y="2487168"/>
             <a:ext cx="6583680" cy="411480"/>
           </a:xfrm>
           <a:prstGeom prst="rect">
@@ -2260,7 +2260,7 @@
         </p:nvSpPr>
         <p:spPr>
           <a:xfrm>
-            <a:off x="640080" y="3154680"/>
+            <a:off x="640080" y="2944368"/>
             <a:ext cx="1097280" cy="411480"/>
           </a:xfrm>
           <a:prstGeom prst="rect">
@@ -2299,7 +2299,7 @@
         </p:nvSpPr>
         <p:spPr>
           <a:xfrm>
-            <a:off x="1828800" y="3154680"/>
+            <a:off x="1828800" y="2944368"/>
             <a:ext cx="6583680" cy="411480"/>
           </a:xfrm>
           <a:prstGeom prst="rect">
@@ -2338,7 +2338,7 @@
         </p:nvSpPr>
         <p:spPr>
           <a:xfrm>
-            <a:off x="640080" y="3657600"/>
+            <a:off x="640080" y="3401568"/>
             <a:ext cx="1097280" cy="411480"/>
           </a:xfrm>
           <a:prstGeom prst="rect">
@@ -2377,7 +2377,7 @@
         </p:nvSpPr>
         <p:spPr>
           <a:xfrm>
-            <a:off x="1828800" y="3657600"/>
+            <a:off x="1828800" y="3401568"/>
             <a:ext cx="6583680" cy="411480"/>
           </a:xfrm>
           <a:prstGeom prst="rect">
@@ -2416,7 +2416,7 @@
         </p:nvSpPr>
         <p:spPr>
           <a:xfrm>
-            <a:off x="640080" y="4160520"/>
+            <a:off x="640080" y="3858768"/>
             <a:ext cx="1097280" cy="411480"/>
           </a:xfrm>
           <a:prstGeom prst="rect">
@@ -2455,7 +2455,7 @@
         </p:nvSpPr>
         <p:spPr>
           <a:xfrm>
-            <a:off x="1828800" y="4160520"/>
+            <a:off x="1828800" y="3858768"/>
             <a:ext cx="6583680" cy="411480"/>
           </a:xfrm>
           <a:prstGeom prst="rect">

</xml_diff>